<commit_message>
Finalize AegisOne multi-brand AI Marketing CFO
</commit_message>
<xml_diff>
--- a/docs/AegisOne_Autonomous_Marketing_CFO.pptx
+++ b/docs/AegisOne_Autonomous_Marketing_CFO.pptx
@@ -17,6 +17,7 @@
     <p:sldId id="265" r:id="rId16"/>
     <p:sldId id="266" r:id="rId17"/>
     <p:sldId id="267" r:id="rId18"/>
+    <p:sldId id="268" r:id="rId19"/>
   </p:sldIdLst>
   <p:sldSz cx="12191695" cy="6858000" type="screen4x3"/>
   <p:notesSz cx="6858000" cy="9144000"/>
@@ -173,16 +174,16 @@
                 <c:formatCode>General</c:formatCode>
                 <c:ptCount val="4"/>
                 <c:pt idx="0">
-                  <c:v>6.7</c:v>
+                  <c:v>7.96</c:v>
                 </c:pt>
                 <c:pt idx="1">
-                  <c:v>5.25</c:v>
+                  <c:v>6.17</c:v>
                 </c:pt>
                 <c:pt idx="2">
-                  <c:v>4.82</c:v>
+                  <c:v>5.76</c:v>
                 </c:pt>
                 <c:pt idx="3">
-                  <c:v>5.4</c:v>
+                  <c:v>6.54</c:v>
                 </c:pt>
               </c:numCache>
             </c:numRef>
@@ -234,16 +235,16 @@
                 <c:formatCode>General</c:formatCode>
                 <c:ptCount val="4"/>
                 <c:pt idx="0">
-                  <c:v>5.58</c:v>
+                  <c:v>7.04</c:v>
                 </c:pt>
                 <c:pt idx="1">
-                  <c:v>4.35</c:v>
+                  <c:v>4.68</c:v>
                 </c:pt>
                 <c:pt idx="2">
-                  <c:v>4.0</c:v>
+                  <c:v>5.11</c:v>
                 </c:pt>
                 <c:pt idx="3">
-                  <c:v>4.17</c:v>
+                  <c:v>4.7</c:v>
                 </c:pt>
               </c:numCache>
             </c:numRef>
@@ -397,41 +398,47 @@
           </c:spPr>
           <c:cat>
             <c:strRef>
-              <c:f>Sheet1!$A$2:$A$5</c:f>
+              <c:f>Sheet1!$A$2:$A$6</c:f>
               <c:strCache>
-                <c:ptCount val="4"/>
+                <c:ptCount val="5"/>
                 <c:pt idx="0">
-                  <c:v>Premium Fashion</c:v>
+                  <c:v>Nike</c:v>
                 </c:pt>
                 <c:pt idx="1">
-                  <c:v>D2C Startup</c:v>
+                  <c:v>Samsung</c:v>
                 </c:pt>
                 <c:pt idx="2">
-                  <c:v>Consumer Electronics</c:v>
+                  <c:v>Lenovo</c:v>
                 </c:pt>
                 <c:pt idx="3">
-                  <c:v>Food / Perishable</c:v>
+                  <c:v>Louis Vuitton</c:v>
+                </c:pt>
+                <c:pt idx="4">
+                  <c:v>Supreme</c:v>
                 </c:pt>
               </c:strCache>
             </c:strRef>
           </c:cat>
           <c:val>
             <c:numRef>
-              <c:f>Sheet1!$B$2:$B$5</c:f>
+              <c:f>Sheet1!$B$2:$B$6</c:f>
               <c:numCache>
                 <c:formatCode>General</c:formatCode>
-                <c:ptCount val="4"/>
+                <c:ptCount val="5"/>
                 <c:pt idx="0">
-                  <c:v>0.28</c:v>
+                  <c:v>0.24</c:v>
                 </c:pt>
                 <c:pt idx="1">
-                  <c:v>0.12</c:v>
+                  <c:v>0.27</c:v>
                 </c:pt>
                 <c:pt idx="2">
+                  <c:v>0.34</c:v>
+                </c:pt>
+                <c:pt idx="3">
                   <c:v>0.3</c:v>
                 </c:pt>
-                <c:pt idx="3">
-                  <c:v>0.18</c:v>
+                <c:pt idx="4">
+                  <c:v>0.24</c:v>
                 </c:pt>
               </c:numCache>
             </c:numRef>
@@ -458,41 +465,47 @@
           </c:spPr>
           <c:cat>
             <c:strRef>
-              <c:f>Sheet1!$A$2:$A$5</c:f>
+              <c:f>Sheet1!$A$2:$A$6</c:f>
               <c:strCache>
-                <c:ptCount val="4"/>
+                <c:ptCount val="5"/>
                 <c:pt idx="0">
-                  <c:v>Premium Fashion</c:v>
+                  <c:v>Nike</c:v>
                 </c:pt>
                 <c:pt idx="1">
-                  <c:v>D2C Startup</c:v>
+                  <c:v>Samsung</c:v>
                 </c:pt>
                 <c:pt idx="2">
-                  <c:v>Consumer Electronics</c:v>
+                  <c:v>Lenovo</c:v>
                 </c:pt>
                 <c:pt idx="3">
-                  <c:v>Food / Perishable</c:v>
+                  <c:v>Louis Vuitton</c:v>
+                </c:pt>
+                <c:pt idx="4">
+                  <c:v>Supreme</c:v>
                 </c:pt>
               </c:strCache>
             </c:strRef>
           </c:cat>
           <c:val>
             <c:numRef>
-              <c:f>Sheet1!$C$2:$C$5</c:f>
+              <c:f>Sheet1!$C$2:$C$6</c:f>
               <c:numCache>
                 <c:formatCode>General</c:formatCode>
-                <c:ptCount val="4"/>
+                <c:ptCount val="5"/>
                 <c:pt idx="0">
-                  <c:v>0.1</c:v>
+                  <c:v>0.24</c:v>
                 </c:pt>
                 <c:pt idx="1">
-                  <c:v>0.32</c:v>
+                  <c:v>0.08</c:v>
                 </c:pt>
                 <c:pt idx="2">
-                  <c:v>0.08</c:v>
+                  <c:v>0.06</c:v>
                 </c:pt>
                 <c:pt idx="3">
-                  <c:v>0.12</c:v>
+                  <c:v>0.04</c:v>
+                </c:pt>
+                <c:pt idx="4">
+                  <c:v>0.14</c:v>
                 </c:pt>
               </c:numCache>
             </c:numRef>
@@ -519,41 +532,47 @@
           </c:spPr>
           <c:cat>
             <c:strRef>
-              <c:f>Sheet1!$A$2:$A$5</c:f>
+              <c:f>Sheet1!$A$2:$A$6</c:f>
               <c:strCache>
-                <c:ptCount val="4"/>
+                <c:ptCount val="5"/>
                 <c:pt idx="0">
-                  <c:v>Premium Fashion</c:v>
+                  <c:v>Nike</c:v>
                 </c:pt>
                 <c:pt idx="1">
-                  <c:v>D2C Startup</c:v>
+                  <c:v>Samsung</c:v>
                 </c:pt>
                 <c:pt idx="2">
-                  <c:v>Consumer Electronics</c:v>
+                  <c:v>Lenovo</c:v>
                 </c:pt>
                 <c:pt idx="3">
-                  <c:v>Food / Perishable</c:v>
+                  <c:v>Louis Vuitton</c:v>
+                </c:pt>
+                <c:pt idx="4">
+                  <c:v>Supreme</c:v>
                 </c:pt>
               </c:strCache>
             </c:strRef>
           </c:cat>
           <c:val>
             <c:numRef>
-              <c:f>Sheet1!$D$2:$D$5</c:f>
+              <c:f>Sheet1!$D$2:$D$6</c:f>
               <c:numCache>
                 <c:formatCode>General</c:formatCode>
-                <c:ptCount val="4"/>
+                <c:ptCount val="5"/>
                 <c:pt idx="0">
-                  <c:v>0.12</c:v>
+                  <c:v>0.16</c:v>
                 </c:pt>
                 <c:pt idx="1">
-                  <c:v>0.2</c:v>
+                  <c:v>0.15</c:v>
                 </c:pt>
                 <c:pt idx="2">
-                  <c:v>0.2</c:v>
+                  <c:v>0.14</c:v>
                 </c:pt>
                 <c:pt idx="3">
-                  <c:v>0.12</c:v>
+                  <c:v>0.1</c:v>
+                </c:pt>
+                <c:pt idx="4">
+                  <c:v>0.1</c:v>
                 </c:pt>
               </c:numCache>
             </c:numRef>
@@ -580,41 +599,47 @@
           </c:spPr>
           <c:cat>
             <c:strRef>
-              <c:f>Sheet1!$A$2:$A$5</c:f>
+              <c:f>Sheet1!$A$2:$A$6</c:f>
               <c:strCache>
-                <c:ptCount val="4"/>
+                <c:ptCount val="5"/>
                 <c:pt idx="0">
-                  <c:v>Premium Fashion</c:v>
+                  <c:v>Nike</c:v>
                 </c:pt>
                 <c:pt idx="1">
-                  <c:v>D2C Startup</c:v>
+                  <c:v>Samsung</c:v>
                 </c:pt>
                 <c:pt idx="2">
-                  <c:v>Consumer Electronics</c:v>
+                  <c:v>Lenovo</c:v>
                 </c:pt>
                 <c:pt idx="3">
-                  <c:v>Food / Perishable</c:v>
+                  <c:v>Louis Vuitton</c:v>
+                </c:pt>
+                <c:pt idx="4">
+                  <c:v>Supreme</c:v>
                 </c:pt>
               </c:strCache>
             </c:strRef>
           </c:cat>
           <c:val>
             <c:numRef>
-              <c:f>Sheet1!$E$2:$E$5</c:f>
+              <c:f>Sheet1!$E$2:$E$6</c:f>
               <c:numCache>
                 <c:formatCode>General</c:formatCode>
-                <c:ptCount val="4"/>
+                <c:ptCount val="5"/>
                 <c:pt idx="0">
+                  <c:v>0.08</c:v>
+                </c:pt>
+                <c:pt idx="1">
+                  <c:v>0.22</c:v>
+                </c:pt>
+                <c:pt idx="2">
+                  <c:v>0.12</c:v>
+                </c:pt>
+                <c:pt idx="3">
                   <c:v>0.1</c:v>
                 </c:pt>
-                <c:pt idx="1">
-                  <c:v>0.06</c:v>
-                </c:pt>
-                <c:pt idx="2">
-                  <c:v>0.15</c:v>
-                </c:pt>
-                <c:pt idx="3">
-                  <c:v>0.3</c:v>
+                <c:pt idx="4">
+                  <c:v>0.22</c:v>
                 </c:pt>
               </c:numCache>
             </c:numRef>
@@ -641,41 +666,47 @@
           </c:spPr>
           <c:cat>
             <c:strRef>
-              <c:f>Sheet1!$A$2:$A$5</c:f>
+              <c:f>Sheet1!$A$2:$A$6</c:f>
               <c:strCache>
-                <c:ptCount val="4"/>
+                <c:ptCount val="5"/>
                 <c:pt idx="0">
-                  <c:v>Premium Fashion</c:v>
+                  <c:v>Nike</c:v>
                 </c:pt>
                 <c:pt idx="1">
-                  <c:v>D2C Startup</c:v>
+                  <c:v>Samsung</c:v>
                 </c:pt>
                 <c:pt idx="2">
-                  <c:v>Consumer Electronics</c:v>
+                  <c:v>Lenovo</c:v>
                 </c:pt>
                 <c:pt idx="3">
-                  <c:v>Food / Perishable</c:v>
+                  <c:v>Louis Vuitton</c:v>
+                </c:pt>
+                <c:pt idx="4">
+                  <c:v>Supreme</c:v>
                 </c:pt>
               </c:strCache>
             </c:strRef>
           </c:cat>
           <c:val>
             <c:numRef>
-              <c:f>Sheet1!$F$2:$F$5</c:f>
+              <c:f>Sheet1!$F$2:$F$6</c:f>
               <c:numCache>
                 <c:formatCode>General</c:formatCode>
-                <c:ptCount val="4"/>
+                <c:ptCount val="5"/>
                 <c:pt idx="0">
-                  <c:v>0.15</c:v>
+                  <c:v>0.13</c:v>
                 </c:pt>
                 <c:pt idx="1">
-                  <c:v>0.18</c:v>
+                  <c:v>0.13</c:v>
                 </c:pt>
                 <c:pt idx="2">
-                  <c:v>0.12</c:v>
+                  <c:v>0.2</c:v>
                 </c:pt>
                 <c:pt idx="3">
-                  <c:v>0.13</c:v>
+                  <c:v>0.1</c:v>
+                </c:pt>
+                <c:pt idx="4">
+                  <c:v>0.1</c:v>
                 </c:pt>
               </c:numCache>
             </c:numRef>
@@ -702,41 +733,47 @@
           </c:spPr>
           <c:cat>
             <c:strRef>
-              <c:f>Sheet1!$A$2:$A$5</c:f>
+              <c:f>Sheet1!$A$2:$A$6</c:f>
               <c:strCache>
-                <c:ptCount val="4"/>
+                <c:ptCount val="5"/>
                 <c:pt idx="0">
-                  <c:v>Premium Fashion</c:v>
+                  <c:v>Nike</c:v>
                 </c:pt>
                 <c:pt idx="1">
-                  <c:v>D2C Startup</c:v>
+                  <c:v>Samsung</c:v>
                 </c:pt>
                 <c:pt idx="2">
-                  <c:v>Consumer Electronics</c:v>
+                  <c:v>Lenovo</c:v>
                 </c:pt>
                 <c:pt idx="3">
-                  <c:v>Food / Perishable</c:v>
+                  <c:v>Louis Vuitton</c:v>
+                </c:pt>
+                <c:pt idx="4">
+                  <c:v>Supreme</c:v>
                 </c:pt>
               </c:strCache>
             </c:strRef>
           </c:cat>
           <c:val>
             <c:numRef>
-              <c:f>Sheet1!$G$2:$G$5</c:f>
+              <c:f>Sheet1!$G$2:$G$6</c:f>
               <c:numCache>
                 <c:formatCode>General</c:formatCode>
-                <c:ptCount val="4"/>
+                <c:ptCount val="5"/>
                 <c:pt idx="0">
-                  <c:v>0.25</c:v>
+                  <c:v>0.15</c:v>
                 </c:pt>
                 <c:pt idx="1">
-                  <c:v>0.12</c:v>
+                  <c:v>0.15</c:v>
                 </c:pt>
                 <c:pt idx="2">
-                  <c:v>0.15</c:v>
+                  <c:v>0.14</c:v>
                 </c:pt>
                 <c:pt idx="3">
-                  <c:v>0.15</c:v>
+                  <c:v>0.36</c:v>
+                </c:pt>
+                <c:pt idx="4">
+                  <c:v>0.2</c:v>
                 </c:pt>
               </c:numCache>
             </c:numRef>
@@ -1012,139 +1049,139 @@
                 <c:formatCode>General</c:formatCode>
                 <c:ptCount val="45"/>
                 <c:pt idx="0">
-                  <c:v>102.8</c:v>
+                  <c:v>98.1</c:v>
                 </c:pt>
                 <c:pt idx="1">
+                  <c:v>97.7</c:v>
+                </c:pt>
+                <c:pt idx="2">
+                  <c:v>94.4</c:v>
+                </c:pt>
+                <c:pt idx="3">
+                  <c:v>98.2</c:v>
+                </c:pt>
+                <c:pt idx="4">
+                  <c:v>125.2</c:v>
+                </c:pt>
+                <c:pt idx="5">
+                  <c:v>106.9</c:v>
+                </c:pt>
+                <c:pt idx="6">
+                  <c:v>86.7</c:v>
+                </c:pt>
+                <c:pt idx="7">
                   <c:v>100.9</c:v>
                 </c:pt>
-                <c:pt idx="2">
-                  <c:v>96.1</c:v>
-                </c:pt>
-                <c:pt idx="3">
-                  <c:v>95.8</c:v>
-                </c:pt>
-                <c:pt idx="4">
-                  <c:v>114.6</c:v>
-                </c:pt>
-                <c:pt idx="5">
-                  <c:v>107.6</c:v>
-                </c:pt>
-                <c:pt idx="6">
-                  <c:v>90.1</c:v>
-                </c:pt>
-                <c:pt idx="7">
-                  <c:v>98.0</c:v>
-                </c:pt>
                 <c:pt idx="8">
-                  <c:v>88.7</c:v>
+                  <c:v>93.0</c:v>
                 </c:pt>
                 <c:pt idx="9">
-                  <c:v>70.5</c:v>
+                  <c:v>65.5</c:v>
                 </c:pt>
                 <c:pt idx="10">
-                  <c:v>111.3</c:v>
+                  <c:v>110.2</c:v>
                 </c:pt>
                 <c:pt idx="11">
-                  <c:v>98.5</c:v>
+                  <c:v>101.7</c:v>
                 </c:pt>
                 <c:pt idx="12">
-                  <c:v>91.8</c:v>
+                  <c:v>91.0</c:v>
                 </c:pt>
                 <c:pt idx="13">
-                  <c:v>104.5</c:v>
+                  <c:v>98.2</c:v>
                 </c:pt>
                 <c:pt idx="14">
-                  <c:v>124.0</c:v>
+                  <c:v>126.3</c:v>
                 </c:pt>
                 <c:pt idx="15">
-                  <c:v>85.5</c:v>
+                  <c:v>87.3</c:v>
                 </c:pt>
                 <c:pt idx="16">
-                  <c:v>65.3</c:v>
+                  <c:v>62.2</c:v>
                 </c:pt>
                 <c:pt idx="17">
-                  <c:v>92.0</c:v>
+                  <c:v>93.0</c:v>
                 </c:pt>
                 <c:pt idx="18">
-                  <c:v>110.5</c:v>
+                  <c:v>109.7</c:v>
                 </c:pt>
                 <c:pt idx="19">
-                  <c:v>104.3</c:v>
+                  <c:v>104.6</c:v>
                 </c:pt>
                 <c:pt idx="20">
-                  <c:v>148.0</c:v>
+                  <c:v>155.8</c:v>
                 </c:pt>
                 <c:pt idx="21">
-                  <c:v>97.8</c:v>
+                  <c:v>95.3</c:v>
                 </c:pt>
                 <c:pt idx="22">
-                  <c:v>88.5</c:v>
+                  <c:v>85.8</c:v>
                 </c:pt>
                 <c:pt idx="23">
-                  <c:v>115.8</c:v>
+                  <c:v>116.0</c:v>
                 </c:pt>
                 <c:pt idx="24">
-                  <c:v>97.1</c:v>
+                  <c:v>96.2</c:v>
                 </c:pt>
                 <c:pt idx="25">
-                  <c:v>101.5</c:v>
+                  <c:v>100.6</c:v>
                 </c:pt>
                 <c:pt idx="26">
-                  <c:v>100.4</c:v>
+                  <c:v>98.3</c:v>
                 </c:pt>
                 <c:pt idx="27">
-                  <c:v>111.5</c:v>
+                  <c:v>109.2</c:v>
                 </c:pt>
                 <c:pt idx="28">
-                  <c:v>88.3</c:v>
+                  <c:v>83.6</c:v>
                 </c:pt>
                 <c:pt idx="29">
-                  <c:v>99.0</c:v>
+                  <c:v>96.0</c:v>
                 </c:pt>
                 <c:pt idx="30">
-                  <c:v>100.8</c:v>
+                  <c:v>101.8</c:v>
                 </c:pt>
                 <c:pt idx="31">
-                  <c:v>77.0</c:v>
+                  <c:v>77.8</c:v>
                 </c:pt>
                 <c:pt idx="32">
-                  <c:v>99.3</c:v>
+                  <c:v>92.3</c:v>
                 </c:pt>
                 <c:pt idx="33">
-                  <c:v>82.7</c:v>
+                  <c:v>81.7</c:v>
                 </c:pt>
                 <c:pt idx="34">
-                  <c:v>102.9</c:v>
+                  <c:v>104.0</c:v>
                 </c:pt>
                 <c:pt idx="35">
-                  <c:v>109.1</c:v>
+                  <c:v>108.4</c:v>
                 </c:pt>
                 <c:pt idx="36">
-                  <c:v>87.6</c:v>
+                  <c:v>84.8</c:v>
                 </c:pt>
                 <c:pt idx="37">
                   <c:v>95.5</c:v>
                 </c:pt>
                 <c:pt idx="38">
-                  <c:v>114.7</c:v>
+                  <c:v>116.9</c:v>
                 </c:pt>
                 <c:pt idx="39">
-                  <c:v>71.4</c:v>
+                  <c:v>74.7</c:v>
                 </c:pt>
                 <c:pt idx="40">
-                  <c:v>81.1</c:v>
+                  <c:v>81.9</c:v>
                 </c:pt>
                 <c:pt idx="41">
-                  <c:v>44.1</c:v>
+                  <c:v>42.4</c:v>
                 </c:pt>
                 <c:pt idx="42">
-                  <c:v>45.5</c:v>
+                  <c:v>35.4</c:v>
                 </c:pt>
                 <c:pt idx="43">
-                  <c:v>36.9</c:v>
+                  <c:v>35.9</c:v>
                 </c:pt>
                 <c:pt idx="44">
-                  <c:v>47.1</c:v>
+                  <c:v>47.6</c:v>
                 </c:pt>
               </c:numCache>
             </c:numRef>
@@ -1951,139 +1988,139 @@
                 <c:formatCode>General</c:formatCode>
                 <c:ptCount val="45"/>
                 <c:pt idx="0">
-                  <c:v>100.3</c:v>
+                  <c:v>95.9</c:v>
                 </c:pt>
                 <c:pt idx="1">
-                  <c:v>97.1</c:v>
+                  <c:v>94.6</c:v>
                 </c:pt>
                 <c:pt idx="2">
-                  <c:v>91.7</c:v>
+                  <c:v>90.6</c:v>
                 </c:pt>
                 <c:pt idx="3">
-                  <c:v>84.6</c:v>
+                  <c:v>86.6</c:v>
                 </c:pt>
                 <c:pt idx="4">
-                  <c:v>120.7</c:v>
+                  <c:v>131.9</c:v>
                 </c:pt>
                 <c:pt idx="5">
-                  <c:v>105.0</c:v>
+                  <c:v>103.9</c:v>
                 </c:pt>
                 <c:pt idx="6">
-                  <c:v>105.0</c:v>
+                  <c:v>101.3</c:v>
                 </c:pt>
                 <c:pt idx="7">
-                  <c:v>111.3</c:v>
+                  <c:v>114.6</c:v>
                 </c:pt>
                 <c:pt idx="8">
-                  <c:v>99.5</c:v>
+                  <c:v>103.9</c:v>
                 </c:pt>
                 <c:pt idx="9">
-                  <c:v>76.8</c:v>
+                  <c:v>70.6</c:v>
                 </c:pt>
                 <c:pt idx="10">
-                  <c:v>97.9</c:v>
+                  <c:v>97.3</c:v>
                 </c:pt>
                 <c:pt idx="11">
-                  <c:v>97.1</c:v>
+                  <c:v>99.9</c:v>
                 </c:pt>
                 <c:pt idx="12">
-                  <c:v>91.7</c:v>
+                  <c:v>90.6</c:v>
                 </c:pt>
                 <c:pt idx="13">
-                  <c:v>98.7</c:v>
+                  <c:v>93.3</c:v>
                 </c:pt>
                 <c:pt idx="14">
-                  <c:v>120.7</c:v>
+                  <c:v>122.6</c:v>
                 </c:pt>
                 <c:pt idx="15">
-                  <c:v>93.2</c:v>
+                  <c:v>94.6</c:v>
                 </c:pt>
                 <c:pt idx="16">
-                  <c:v>68.9</c:v>
+                  <c:v>65.3</c:v>
                 </c:pt>
                 <c:pt idx="17">
-                  <c:v>94.0</c:v>
+                  <c:v>94.6</c:v>
                 </c:pt>
                 <c:pt idx="18">
-                  <c:v>100.3</c:v>
+                  <c:v>99.9</c:v>
                 </c:pt>
                 <c:pt idx="19">
-                  <c:v>107.3</c:v>
+                  <c:v>107.9</c:v>
                 </c:pt>
                 <c:pt idx="20">
-                  <c:v>137.1</c:v>
+                  <c:v>143.9</c:v>
                 </c:pt>
                 <c:pt idx="21">
-                  <c:v>103.4</c:v>
+                  <c:v>101.3</c:v>
                 </c:pt>
                 <c:pt idx="22">
-                  <c:v>87.0</c:v>
+                  <c:v>84.0</c:v>
                 </c:pt>
                 <c:pt idx="23">
-                  <c:v>113.6</c:v>
+                  <c:v>113.3</c:v>
                 </c:pt>
                 <c:pt idx="24">
-                  <c:v>97.1</c:v>
+                  <c:v>97.3</c:v>
                 </c:pt>
                 <c:pt idx="25">
-                  <c:v>101.1</c:v>
+                  <c:v>99.9</c:v>
                 </c:pt>
                 <c:pt idx="26">
-                  <c:v>104.2</c:v>
+                  <c:v>102.6</c:v>
                 </c:pt>
                 <c:pt idx="27">
-                  <c:v>110.5</c:v>
+                  <c:v>107.9</c:v>
                 </c:pt>
                 <c:pt idx="28">
-                  <c:v>91.7</c:v>
+                  <c:v>86.6</c:v>
                 </c:pt>
                 <c:pt idx="29">
-                  <c:v>108.1</c:v>
+                  <c:v>105.3</c:v>
                 </c:pt>
                 <c:pt idx="30">
-                  <c:v>87.7</c:v>
+                  <c:v>89.3</c:v>
                 </c:pt>
                 <c:pt idx="31">
-                  <c:v>83.0</c:v>
+                  <c:v>84.0</c:v>
                 </c:pt>
                 <c:pt idx="32">
+                  <c:v>82.6</c:v>
+                </c:pt>
+                <c:pt idx="33">
+                  <c:v>86.6</c:v>
+                </c:pt>
+                <c:pt idx="34">
+                  <c:v>107.9</c:v>
+                </c:pt>
+                <c:pt idx="35">
+                  <c:v>109.3</c:v>
+                </c:pt>
+                <c:pt idx="36">
+                  <c:v>97.3</c:v>
+                </c:pt>
+                <c:pt idx="37">
+                  <c:v>95.9</c:v>
+                </c:pt>
+                <c:pt idx="38">
+                  <c:v>106.6</c:v>
+                </c:pt>
+                <c:pt idx="39">
+                  <c:v>106.6</c:v>
+                </c:pt>
+                <c:pt idx="40">
+                  <c:v>121.3</c:v>
+                </c:pt>
+                <c:pt idx="41">
+                  <c:v>95.9</c:v>
+                </c:pt>
+                <c:pt idx="42">
+                  <c:v>76.0</c:v>
+                </c:pt>
+                <c:pt idx="43">
                   <c:v>89.3</c:v>
                 </c:pt>
-                <c:pt idx="33">
-                  <c:v>87.0</c:v>
-                </c:pt>
-                <c:pt idx="34">
-                  <c:v>106.5</c:v>
-                </c:pt>
-                <c:pt idx="35">
-                  <c:v>110.5</c:v>
-                </c:pt>
-                <c:pt idx="36">
-                  <c:v>99.5</c:v>
-                </c:pt>
-                <c:pt idx="37">
-                  <c:v>95.6</c:v>
-                </c:pt>
-                <c:pt idx="38">
-                  <c:v>104.2</c:v>
-                </c:pt>
-                <c:pt idx="39">
-                  <c:v>101.8</c:v>
-                </c:pt>
-                <c:pt idx="40">
-                  <c:v>119.9</c:v>
-                </c:pt>
-                <c:pt idx="41">
-                  <c:v>99.5</c:v>
-                </c:pt>
-                <c:pt idx="42">
-                  <c:v>97.1</c:v>
-                </c:pt>
-                <c:pt idx="43">
-                  <c:v>91.7</c:v>
-                </c:pt>
                 <c:pt idx="44">
-                  <c:v>109.7</c:v>
+                  <c:v>110.6</c:v>
                 </c:pt>
               </c:numCache>
             </c:numRef>
@@ -2231,40 +2268,40 @@
               <c:strCache>
                 <c:ptCount val="12"/>
                 <c:pt idx="0">
-                  <c:v>Linen Blazer Meta LAL</c:v>
+                  <c:v>Air Jordan 10 Retro Meta LAL</c:v>
                 </c:pt>
                 <c:pt idx="1">
-                  <c:v>Linen Blazer Google RT</c:v>
+                  <c:v>Air Jordan 10 Retro Google RT</c:v>
                 </c:pt>
                 <c:pt idx="2">
-                  <c:v>Silk Scarf Google Interest</c:v>
+                  <c:v>Nike Zoom Fly Google Interest</c:v>
                 </c:pt>
                 <c:pt idx="3">
-                  <c:v>Silk Scarf Instagram LAL</c:v>
+                  <c:v>Nike Zoom Fly Instagram LAL</c:v>
                 </c:pt>
                 <c:pt idx="4">
-                  <c:v>Selvedge Denim Meta Broad</c:v>
+                  <c:v>Nike Air Monarch IV Meta Broad</c:v>
                 </c:pt>
                 <c:pt idx="5">
-                  <c:v>Selvedge Denim Google RT</c:v>
+                  <c:v>Nike Air Monarch IV Google RT</c:v>
                 </c:pt>
                 <c:pt idx="6">
-                  <c:v>Evening Dress Instagram LAL</c:v>
+                  <c:v>Nike Air Max 270 Instagram LAL</c:v>
                 </c:pt>
                 <c:pt idx="7">
-                  <c:v>Evening Dress YouTube Broad</c:v>
+                  <c:v>Nike Air Max 270 YouTube Broad</c:v>
                 </c:pt>
                 <c:pt idx="8">
-                  <c:v>Leather Tote Meta RT</c:v>
+                  <c:v>Nike Epic React Flyknit 2 Meta RT</c:v>
                 </c:pt>
                 <c:pt idx="9">
-                  <c:v>Leather Tote Google Interest</c:v>
+                  <c:v>Nike Epic React Flyknit 2 Google Interest</c:v>
                 </c:pt>
                 <c:pt idx="10">
-                  <c:v>Court Sneaker Meta Broad</c:v>
+                  <c:v>Nike Free X Metcon 2 Meta Broad</c:v>
                 </c:pt>
                 <c:pt idx="11">
-                  <c:v>Court Sneaker Instagram LAL</c:v>
+                  <c:v>Nike Free X Metcon 2 Instagram LAL</c:v>
                 </c:pt>
               </c:strCache>
             </c:strRef>
@@ -2340,40 +2377,40 @@
               <c:strCache>
                 <c:ptCount val="12"/>
                 <c:pt idx="0">
-                  <c:v>Linen Blazer Meta LAL</c:v>
+                  <c:v>Air Jordan 10 Retro Meta LAL</c:v>
                 </c:pt>
                 <c:pt idx="1">
-                  <c:v>Linen Blazer Google RT</c:v>
+                  <c:v>Air Jordan 10 Retro Google RT</c:v>
                 </c:pt>
                 <c:pt idx="2">
-                  <c:v>Silk Scarf Google Interest</c:v>
+                  <c:v>Nike Zoom Fly Google Interest</c:v>
                 </c:pt>
                 <c:pt idx="3">
-                  <c:v>Silk Scarf Instagram LAL</c:v>
+                  <c:v>Nike Zoom Fly Instagram LAL</c:v>
                 </c:pt>
                 <c:pt idx="4">
-                  <c:v>Selvedge Denim Meta Broad</c:v>
+                  <c:v>Nike Air Monarch IV Meta Broad</c:v>
                 </c:pt>
                 <c:pt idx="5">
-                  <c:v>Selvedge Denim Google RT</c:v>
+                  <c:v>Nike Air Monarch IV Google RT</c:v>
                 </c:pt>
                 <c:pt idx="6">
-                  <c:v>Evening Dress Instagram LAL</c:v>
+                  <c:v>Nike Air Max 270 Instagram LAL</c:v>
                 </c:pt>
                 <c:pt idx="7">
-                  <c:v>Evening Dress YouTube Broad</c:v>
+                  <c:v>Nike Air Max 270 YouTube Broad</c:v>
                 </c:pt>
                 <c:pt idx="8">
-                  <c:v>Leather Tote Meta RT</c:v>
+                  <c:v>Nike Epic React Flyknit 2 Meta RT</c:v>
                 </c:pt>
                 <c:pt idx="9">
-                  <c:v>Leather Tote Google Interest</c:v>
+                  <c:v>Nike Epic React Flyknit 2 Google Interest</c:v>
                 </c:pt>
                 <c:pt idx="10">
-                  <c:v>Court Sneaker Meta Broad</c:v>
+                  <c:v>Nike Free X Metcon 2 Meta Broad</c:v>
                 </c:pt>
                 <c:pt idx="11">
-                  <c:v>Court Sneaker Instagram LAL</c:v>
+                  <c:v>Nike Free X Metcon 2 Instagram LAL</c:v>
                 </c:pt>
               </c:strCache>
             </c:strRef>
@@ -2388,7 +2425,7 @@
                   <c:v>28000.0</c:v>
                 </c:pt>
                 <c:pt idx="1">
-                  <c:v>21000.0</c:v>
+                  <c:v>14000.0</c:v>
                 </c:pt>
                 <c:pt idx="2">
                   <c:v>44000.0</c:v>
@@ -2397,13 +2434,13 @@
                   <c:v>12000.0</c:v>
                 </c:pt>
                 <c:pt idx="4">
-                  <c:v>19000.0</c:v>
+                  <c:v>20000.0</c:v>
                 </c:pt>
                 <c:pt idx="5">
-                  <c:v>11000.0</c:v>
+                  <c:v>18000.0</c:v>
                 </c:pt>
                 <c:pt idx="6">
-                  <c:v>18000.0</c:v>
+                  <c:v>17000.0</c:v>
                 </c:pt>
                 <c:pt idx="7">
                   <c:v>7000.0</c:v>
@@ -5741,7 +5778,7 @@
                 </a:solidFill>
                 <a:latin typeface="Segoe UI"/>
               </a:rPr>
-              <a:t>1 / 12</a:t>
+              <a:t>1 / 13</a:t>
             </a:r>
           </a:p>
         </p:txBody>
@@ -5948,7 +5985,7 @@
                 </a:solidFill>
                 <a:latin typeface="Segoe UI"/>
               </a:rPr>
-              <a:t>4.8×</a:t>
+              <a:t>5.8×</a:t>
             </a:r>
           </a:p>
         </p:txBody>
@@ -6143,7 +6180,7 @@
                 </a:solidFill>
                 <a:latin typeface="Segoe UI"/>
               </a:rPr>
-              <a:t>6.7×</a:t>
+              <a:t>8.0×</a:t>
             </a:r>
           </a:p>
         </p:txBody>
@@ -6338,7 +6375,7 @@
                 </a:solidFill>
                 <a:latin typeface="Segoe UI"/>
               </a:rPr>
-              <a:t>5.2×</a:t>
+              <a:t>6.2×</a:t>
             </a:r>
           </a:p>
         </p:txBody>
@@ -6533,7 +6570,7 @@
                 </a:solidFill>
                 <a:latin typeface="Segoe UI"/>
               </a:rPr>
-              <a:t>5.4×</a:t>
+              <a:t>6.5×</a:t>
             </a:r>
           </a:p>
         </p:txBody>
@@ -6603,7 +6640,7 @@
                 </a:solidFill>
                 <a:latin typeface="Segoe UI"/>
               </a:rPr>
-              <a:t>Every platform grades its own homework. Together they claim 21% more orders than the store actually shipped.</a:t>
+              <a:t>Every platform grades its own homework. Together they claim 16% more orders than the store actually shipped.</a:t>
             </a:r>
           </a:p>
         </p:txBody>
@@ -7464,7 +7501,7 @@
                 </a:solidFill>
                 <a:latin typeface="Segoe UI"/>
               </a:rPr>
-              <a:t>10 / 12</a:t>
+              <a:t>10 / 13</a:t>
             </a:r>
           </a:p>
         </p:txBody>
@@ -7589,7 +7626,7 @@
                 </a:solidFill>
                 <a:latin typeface="Segoe UI"/>
               </a:rPr>
-              <a:t>Data</a:t>
+              <a:t>Public data → simulation</a:t>
             </a:r>
           </a:p>
         </p:txBody>
@@ -7624,8 +7661,8 @@
                 </a:solidFill>
                 <a:latin typeface="Segoe UI"/>
               </a:rPr>
-              <a:t>Synthetic generator · SQLite
-14 tables · 4 companies · 60 days</a:t>
+              <a:t>ingest.py · public catalogs · SQLite
+15 tables · 5 brands · simulated ads</a:t>
             </a:r>
           </a:p>
         </p:txBody>
@@ -7786,7 +7823,7 @@
                 </a:solidFill>
                 <a:latin typeface="Segoe UI"/>
               </a:rPr>
-              <a:t>Ingest &amp; reconcile</a:t>
+              <a:t>ML prediction</a:t>
             </a:r>
           </a:p>
         </p:txBody>
@@ -7821,8 +7858,8 @@
                 </a:solidFill>
                 <a:latin typeface="Segoe UI"/>
               </a:rPr>
-              <a:t>pandas · scikit-learn
-sales ↔ platform regression</a:t>
+              <a:t>Poisson GBM conversion signal
+bounded multiplier, never the decider</a:t>
             </a:r>
           </a:p>
         </p:txBody>
@@ -8144,7 +8181,7 @@
                 </a:solidFill>
                 <a:latin typeface="Segoe UI"/>
               </a:rPr>
-              <a:t>Policy engine</a:t>
+              <a:t>Policy &amp; guardrails</a:t>
             </a:r>
           </a:p>
         </p:txBody>
@@ -8179,8 +8216,8 @@
                 </a:solidFill>
                 <a:latin typeface="Segoe UI"/>
               </a:rPr>
-              <a:t>6 weights + 4 guardrails
-per company</a:t>
+              <a:t>6 weights + 4 guardrails per brand
+margin · ROAS · CAC · stock can override ML</a:t>
             </a:r>
           </a:p>
         </p:txBody>
@@ -8728,19 +8765,31 @@
                 </a:solidFill>
                 <a:latin typeface="Segoe UI"/>
               </a:rPr>
+              <a:t>/ml/card  /ml/trace</a:t>
+            </a:r>
+          </a:p>
+          <a:p>
+            <a:pPr algn="l"/>
+            <a:r>
+              <a:rPr sz="1100" b="0" i="0">
+                <a:solidFill>
+                  <a:srgbClr val="ECF1F9"/>
+                </a:solidFill>
+                <a:latin typeface="Segoe UI"/>
+              </a:rPr>
+              <a:t>/data-sources  /brands</a:t>
+            </a:r>
+          </a:p>
+          <a:p>
+            <a:pPr algn="l"/>
+            <a:r>
+              <a:rPr sz="1100" b="0" i="0">
+                <a:solidFill>
+                  <a:srgbClr val="ECF1F9"/>
+                </a:solidFill>
+                <a:latin typeface="Segoe UI"/>
+              </a:rPr>
               <a:t>/recommendations/decide</a:t>
-            </a:r>
-          </a:p>
-          <a:p>
-            <a:pPr algn="l"/>
-            <a:r>
-              <a:rPr sz="1100" b="0" i="0">
-                <a:solidFill>
-                  <a:srgbClr val="ECF1F9"/>
-                </a:solidFill>
-                <a:latin typeface="Segoe UI"/>
-              </a:rPr>
-              <a:t>/history  /demo</a:t>
             </a:r>
           </a:p>
         </p:txBody>
@@ -8857,7 +8906,7 @@
                 <a:latin typeface="Segoe UI"/>
               </a:rPr>
               <a:t>Recharts dashboard
-7 decision views</a:t>
+9 views incl. ML Lab, Data Sources</a:t>
             </a:r>
           </a:p>
         </p:txBody>
@@ -8983,7 +9032,7 @@
                 </a:solidFill>
                 <a:latin typeface="Segoe UI"/>
               </a:rPr>
-              <a:t>every recommendation carries its why, policy drivers, guardrail checks and confidence — and every figure is a deterministic function of the data and the policy.</a:t>
+              <a:t>ML predicts an order signal; the deterministic CFO engine (policy, guardrails, optimizer) decides. Every recommendation carries its why, policy drivers, guardrail checks and confidence.</a:t>
             </a:r>
           </a:p>
         </p:txBody>
@@ -9228,7 +9277,7 @@
                 </a:solidFill>
                 <a:latin typeface="Segoe UI"/>
               </a:rPr>
-              <a:t>11 / 12</a:t>
+              <a:t>11 / 13</a:t>
             </a:r>
           </a:p>
         </p:txBody>
@@ -9388,7 +9437,7 @@
                 </a:solidFill>
                 <a:latin typeface="Segoe UI"/>
               </a:rPr>
-              <a:t>720 daily ad rows reconciled; platforms over-claim 21%</a:t>
+              <a:t>720 daily ad rows reconciled; platforms over-claim 16%</a:t>
             </a:r>
           </a:p>
         </p:txBody>
@@ -9584,7 +9633,7 @@
                 </a:solidFill>
                 <a:latin typeface="Segoe UI"/>
               </a:rPr>
-              <a:t>Linen Blazer · Meta ROAS 6.0→3.0. Creative fatigue, 95% confident</a:t>
+              <a:t>Air Jordan 10 Retro · Meta ROAS 7.2→3.4. Creative fatigue, 95% confident</a:t>
             </a:r>
           </a:p>
         </p:txBody>
@@ -9780,7 +9829,7 @@
                 </a:solidFill>
                 <a:latin typeface="Segoe UI"/>
               </a:rPr>
-              <a:t>Move ₹12,000/day to Silk Scarf · Google. +₹28,513/day, with the why</a:t>
+              <a:t>Move ₹11,000/day to Nike Zoom Fly·Google·Interest. +₹23,536/day, with the why</a:t>
             </a:r>
           </a:p>
         </p:txBody>
@@ -9976,7 +10025,7 @@
                 </a:solidFill>
                 <a:latin typeface="Segoe UI"/>
               </a:rPr>
-              <a:t>Scarf stock → 200 units. Decision flips to Selvedge Denim·Google·RT (₹6,000)</a:t>
+              <a:t>Nike Zoom Fly stock → 105 units. Decision flips to Air Jordan 10 Retro·Google·RT (₹12,000)</a:t>
             </a:r>
           </a:p>
         </p:txBody>
@@ -10172,7 +10221,7 @@
                 </a:solidFill>
                 <a:latin typeface="Segoe UI"/>
               </a:rPr>
-              <a:t>Approve → outcome ₹24,952 vs ₹28,513 predicted; confidence 92%→91%</a:t>
+              <a:t>Approve → outcome ₹19,508 vs ₹23,536 predicted; confidence 89%→87%</a:t>
             </a:r>
           </a:p>
         </p:txBody>
@@ -10457,7 +10506,7 @@
                 </a:solidFill>
                 <a:latin typeface="Segoe UI"/>
               </a:rPr>
-              <a:t>Modelled on synthetic data for Premium Fashion at ₹2.13 L/day — same total spend, smarter allocation.</a:t>
+              <a:t>Modelled on simulated ad performance for Nike at ₹2.1 L/day — same total spend, smarter allocation. Not a measured result.</a:t>
             </a:r>
           </a:p>
         </p:txBody>
@@ -10527,7 +10576,7 @@
                 </a:solidFill>
                 <a:latin typeface="Segoe UI"/>
               </a:rPr>
-              <a:t>12 / 12</a:t>
+              <a:t>12 / 13</a:t>
             </a:r>
           </a:p>
         </p:txBody>
@@ -10608,7 +10657,7 @@
                 </a:solidFill>
                 <a:latin typeface="Segoe UI"/>
               </a:rPr>
-              <a:t>+₹84,751</a:t>
+              <a:t>+₹81,819</a:t>
             </a:r>
           </a:p>
         </p:txBody>
@@ -10724,7 +10773,7 @@
                 </a:solidFill>
                 <a:latin typeface="Segoe UI"/>
               </a:rPr>
-              <a:t>≈ ₹25.4 L</a:t>
+              <a:t>≈ ₹24.5 L</a:t>
             </a:r>
           </a:p>
         </p:txBody>
@@ -10840,7 +10889,7 @@
                 </a:solidFill>
                 <a:latin typeface="Segoe UI"/>
               </a:rPr>
-              <a:t>7 actions</a:t>
+              <a:t>6 actions</a:t>
             </a:r>
           </a:p>
         </p:txBody>
@@ -11107,7 +11156,7 @@
                 </a:solidFill>
                 <a:latin typeface="Segoe UI"/>
               </a:rPr>
-              <a:t>4 companies → 4 different CFOs</a:t>
+              <a:t>5 brands → 5 different CFOs</a:t>
             </a:r>
           </a:p>
         </p:txBody>
@@ -11462,6 +11511,650 @@
                 <a:latin typeface="Segoe UI"/>
               </a:rPr>
               <a:t>Next: live ad-API connectors · multi-touch &amp; incrementality tests · bandit exploration · creative generation.</a:t>
+            </a:r>
+          </a:p>
+        </p:txBody>
+      </p:sp>
+    </p:spTree>
+  </p:cSld>
+  <p:clrMapOvr>
+    <a:masterClrMapping/>
+  </p:clrMapOvr>
+</p:sld>
+</file>
+
+<file path=ppt/slides/slide13.xml><?xml version="1.0" encoding="utf-8"?>
+<p:sld xmlns:a="http://schemas.openxmlformats.org/drawingml/2006/main" xmlns:p="http://schemas.openxmlformats.org/presentationml/2006/main" xmlns:r="http://schemas.openxmlformats.org/officeDocument/2006/relationships">
+  <p:cSld>
+    <p:bg>
+      <p:bgPr>
+        <a:solidFill>
+          <a:srgbClr val="0A101E"/>
+        </a:solidFill>
+        <a:effectLst/>
+      </p:bgPr>
+    </p:bg>
+    <p:spTree>
+      <p:nvGrpSpPr>
+        <p:cNvPr id="1" name=""/>
+        <p:cNvGrpSpPr/>
+        <p:nvPr/>
+      </p:nvGrpSpPr>
+      <p:grpSpPr/>
+      <p:sp>
+        <p:nvSpPr>
+          <p:cNvPr id="2" name="Rectangle 1"/>
+          <p:cNvSpPr/>
+          <p:nvPr/>
+        </p:nvSpPr>
+        <p:spPr>
+          <a:xfrm>
+            <a:off x="0" y="0"/>
+            <a:ext cx="109728" cy="6858000"/>
+          </a:xfrm>
+          <a:prstGeom prst="rect">
+            <a:avLst/>
+          </a:prstGeom>
+          <a:solidFill>
+            <a:srgbClr val="F5B03A"/>
+          </a:solidFill>
+          <a:ln>
+            <a:noFill/>
+          </a:ln>
+          <a:effectLst/>
+        </p:spPr>
+        <p:style>
+          <a:lnRef idx="1">
+            <a:schemeClr val="accent1"/>
+          </a:lnRef>
+          <a:fillRef idx="3">
+            <a:schemeClr val="accent1"/>
+          </a:fillRef>
+          <a:effectRef idx="2">
+            <a:schemeClr val="accent1"/>
+          </a:effectRef>
+          <a:fontRef idx="minor">
+            <a:schemeClr val="lt1"/>
+          </a:fontRef>
+        </p:style>
+        <p:txBody>
+          <a:bodyPr rtlCol="0" anchor="ctr"/>
+          <a:lstStyle/>
+          <a:p>
+            <a:pPr algn="ctr"/>
+          </a:p>
+        </p:txBody>
+      </p:sp>
+      <p:sp>
+        <p:nvSpPr>
+          <p:cNvPr id="3" name="TextBox 2"/>
+          <p:cNvSpPr txBox="1"/>
+          <p:nvPr/>
+        </p:nvSpPr>
+        <p:spPr>
+          <a:xfrm>
+            <a:off x="594360" y="384048"/>
+            <a:ext cx="8229600" cy="274320"/>
+          </a:xfrm>
+          <a:prstGeom prst="rect">
+            <a:avLst/>
+          </a:prstGeom>
+          <a:noFill/>
+        </p:spPr>
+        <p:txBody>
+          <a:bodyPr wrap="square" lIns="0" rIns="0" tIns="0" bIns="0" anchor="t">
+            <a:spAutoFit/>
+          </a:bodyPr>
+          <a:lstStyle/>
+          <a:p>
+            <a:pPr algn="l"/>
+            <a:r>
+              <a:rPr sz="1100" b="1" i="0">
+                <a:solidFill>
+                  <a:srgbClr val="F5B03A"/>
+                </a:solidFill>
+                <a:latin typeface="Segoe UI"/>
+              </a:rPr>
+              <a:t>13  ·  APPENDIX · ML LAYER &amp; DATA PROVENANCE</a:t>
+            </a:r>
+          </a:p>
+        </p:txBody>
+      </p:sp>
+      <p:sp>
+        <p:nvSpPr>
+          <p:cNvPr id="4" name="TextBox 3"/>
+          <p:cNvSpPr txBox="1"/>
+          <p:nvPr/>
+        </p:nvSpPr>
+        <p:spPr>
+          <a:xfrm>
+            <a:off x="594360" y="713232"/>
+            <a:ext cx="10972800" cy="822960"/>
+          </a:xfrm>
+          <a:prstGeom prst="rect">
+            <a:avLst/>
+          </a:prstGeom>
+          <a:noFill/>
+        </p:spPr>
+        <p:txBody>
+          <a:bodyPr wrap="square" lIns="0" rIns="0" tIns="0" bIns="0" anchor="t">
+            <a:spAutoFit/>
+          </a:bodyPr>
+          <a:lstStyle/>
+          <a:p>
+            <a:pPr algn="l"/>
+            <a:r>
+              <a:rPr sz="3000" b="1" i="0">
+                <a:solidFill>
+                  <a:srgbClr val="ECF1F9"/>
+                </a:solidFill>
+                <a:latin typeface="Segoe UI"/>
+              </a:rPr>
+              <a:t>ML predicts. The CFO decides.</a:t>
+            </a:r>
+          </a:p>
+        </p:txBody>
+      </p:sp>
+      <p:sp>
+        <p:nvSpPr>
+          <p:cNvPr id="5" name="TextBox 4"/>
+          <p:cNvSpPr txBox="1"/>
+          <p:nvPr/>
+        </p:nvSpPr>
+        <p:spPr>
+          <a:xfrm>
+            <a:off x="594360" y="1389888"/>
+            <a:ext cx="10789920" cy="365760"/>
+          </a:xfrm>
+          <a:prstGeom prst="rect">
+            <a:avLst/>
+          </a:prstGeom>
+          <a:noFill/>
+        </p:spPr>
+        <p:txBody>
+          <a:bodyPr wrap="square" lIns="0" rIns="0" tIns="0" bIns="0" anchor="t">
+            <a:spAutoFit/>
+          </a:bodyPr>
+          <a:lstStyle/>
+          <a:p>
+            <a:pPr algn="l"/>
+            <a:r>
+              <a:rPr sz="1400" b="0" i="0">
+                <a:solidFill>
+                  <a:srgbClr val="8F9DB8"/>
+                </a:solidFill>
+                <a:latin typeface="Segoe UI"/>
+              </a:rPr>
+              <a:t>PUBLIC DATA → INGESTION → ML PREDICTION → POLICY → GUARDRAILS → PORTFOLIO OPTIMIZER → NEXT ₹1 → SIMULATION → APPROVAL → FEEDBACK</a:t>
+            </a:r>
+          </a:p>
+        </p:txBody>
+      </p:sp>
+      <p:sp>
+        <p:nvSpPr>
+          <p:cNvPr id="6" name="TextBox 5"/>
+          <p:cNvSpPr txBox="1"/>
+          <p:nvPr/>
+        </p:nvSpPr>
+        <p:spPr>
+          <a:xfrm>
+            <a:off x="594360" y="6473952"/>
+            <a:ext cx="7315200" cy="228600"/>
+          </a:xfrm>
+          <a:prstGeom prst="rect">
+            <a:avLst/>
+          </a:prstGeom>
+          <a:noFill/>
+        </p:spPr>
+        <p:txBody>
+          <a:bodyPr wrap="square" lIns="0" rIns="0" tIns="0" bIns="0" anchor="t">
+            <a:spAutoFit/>
+          </a:bodyPr>
+          <a:lstStyle/>
+          <a:p>
+            <a:pPr algn="l"/>
+            <a:r>
+              <a:rPr sz="900" b="0" i="0">
+                <a:solidFill>
+                  <a:srgbClr val="8F9DB8"/>
+                </a:solidFill>
+                <a:latin typeface="Segoe UI"/>
+              </a:rPr>
+              <a:t>AegisOne · Autonomous Marketing CFO · DataQuest 3.0</a:t>
+            </a:r>
+          </a:p>
+        </p:txBody>
+      </p:sp>
+      <p:sp>
+        <p:nvSpPr>
+          <p:cNvPr id="7" name="TextBox 6"/>
+          <p:cNvSpPr txBox="1"/>
+          <p:nvPr/>
+        </p:nvSpPr>
+        <p:spPr>
+          <a:xfrm>
+            <a:off x="10881360" y="6473952"/>
+            <a:ext cx="731520" cy="228600"/>
+          </a:xfrm>
+          <a:prstGeom prst="rect">
+            <a:avLst/>
+          </a:prstGeom>
+          <a:noFill/>
+        </p:spPr>
+        <p:txBody>
+          <a:bodyPr wrap="square" lIns="0" rIns="0" tIns="0" bIns="0" anchor="t">
+            <a:spAutoFit/>
+          </a:bodyPr>
+          <a:lstStyle/>
+          <a:p>
+            <a:pPr algn="r"/>
+            <a:r>
+              <a:rPr sz="900" b="0" i="0">
+                <a:solidFill>
+                  <a:srgbClr val="8F9DB8"/>
+                </a:solidFill>
+                <a:latin typeface="Segoe UI"/>
+              </a:rPr>
+              <a:t>13 / 13</a:t>
+            </a:r>
+          </a:p>
+        </p:txBody>
+      </p:sp>
+      <p:sp>
+        <p:nvSpPr>
+          <p:cNvPr id="8" name="Rounded Rectangle 7"/>
+          <p:cNvSpPr/>
+          <p:nvPr/>
+        </p:nvSpPr>
+        <p:spPr>
+          <a:xfrm>
+            <a:off x="594360" y="1920240"/>
+            <a:ext cx="5486400" cy="4297680"/>
+          </a:xfrm>
+          <a:prstGeom prst="roundRect">
+            <a:avLst>
+              <a:gd name="adj" fmla="val 6000"/>
+            </a:avLst>
+          </a:prstGeom>
+          <a:solidFill>
+            <a:srgbClr val="121B2F"/>
+          </a:solidFill>
+          <a:ln>
+            <a:noFill/>
+          </a:ln>
+          <a:effectLst/>
+        </p:spPr>
+        <p:style>
+          <a:lnRef idx="1">
+            <a:schemeClr val="accent1"/>
+          </a:lnRef>
+          <a:fillRef idx="3">
+            <a:schemeClr val="accent1"/>
+          </a:fillRef>
+          <a:effectRef idx="2">
+            <a:schemeClr val="accent1"/>
+          </a:effectRef>
+          <a:fontRef idx="minor">
+            <a:schemeClr val="lt1"/>
+          </a:fontRef>
+        </p:style>
+        <p:txBody>
+          <a:bodyPr rtlCol="0" anchor="ctr"/>
+          <a:lstStyle/>
+          <a:p>
+            <a:pPr algn="ctr"/>
+          </a:p>
+        </p:txBody>
+      </p:sp>
+      <p:sp>
+        <p:nvSpPr>
+          <p:cNvPr id="9" name="TextBox 8"/>
+          <p:cNvSpPr txBox="1"/>
+          <p:nvPr/>
+        </p:nvSpPr>
+        <p:spPr>
+          <a:xfrm>
+            <a:off x="822960" y="2057400"/>
+            <a:ext cx="5029200" cy="274320"/>
+          </a:xfrm>
+          <a:prstGeom prst="rect">
+            <a:avLst/>
+          </a:prstGeom>
+          <a:noFill/>
+        </p:spPr>
+        <p:txBody>
+          <a:bodyPr wrap="square" lIns="0" rIns="0" tIns="0" bIns="0" anchor="t">
+            <a:spAutoFit/>
+          </a:bodyPr>
+          <a:lstStyle/>
+          <a:p>
+            <a:pPr algn="l"/>
+            <a:r>
+              <a:rPr sz="1000" b="1" i="0">
+                <a:solidFill>
+                  <a:srgbClr val="F5B03A"/>
+                </a:solidFill>
+                <a:latin typeface="Segoe UI"/>
+              </a:rPr>
+              <a:t>THE MODEL (from model_card.json)</a:t>
+            </a:r>
+          </a:p>
+        </p:txBody>
+      </p:sp>
+      <p:sp>
+        <p:nvSpPr>
+          <p:cNvPr id="10" name="TextBox 9"/>
+          <p:cNvSpPr txBox="1"/>
+          <p:nvPr/>
+        </p:nvSpPr>
+        <p:spPr>
+          <a:xfrm>
+            <a:off x="822960" y="2423160"/>
+            <a:ext cx="5029200" cy="3749039"/>
+          </a:xfrm>
+          <a:prstGeom prst="rect">
+            <a:avLst/>
+          </a:prstGeom>
+          <a:noFill/>
+        </p:spPr>
+        <p:txBody>
+          <a:bodyPr wrap="square" lIns="0" rIns="0" tIns="0" bIns="0" anchor="t">
+            <a:spAutoFit/>
+          </a:bodyPr>
+          <a:lstStyle/>
+          <a:p>
+            <a:pPr algn="l"/>
+            <a:r>
+              <a:rPr sz="1150" b="0" i="0">
+                <a:solidFill>
+                  <a:srgbClr val="ECF1F9"/>
+                </a:solidFill>
+                <a:latin typeface="Segoe UI"/>
+              </a:rPr>
+              <a:t>• Conversion Propensity Model v1.0: HistGradientBoosting (Poisson, depth 2)</a:t>
+            </a:r>
+          </a:p>
+          <a:p>
+            <a:pPr algn="l"/>
+            <a:r>
+              <a:rPr sz="1150" b="0" i="0">
+                <a:solidFill>
+                  <a:srgbClr val="ECF1F9"/>
+                </a:solidFill>
+                <a:latin typeface="Segoe UI"/>
+              </a:rPr>
+              <a:t>• Trained on 936 public Facebook-ad records; target: approved_conversions / clicks (click-weighted)</a:t>
+            </a:r>
+          </a:p>
+          <a:p>
+            <a:pPr algn="l"/>
+            <a:r>
+              <a:rPr sz="1150" b="0" i="0">
+                <a:solidFill>
+                  <a:srgbClr val="ECF1F9"/>
+                </a:solidFill>
+                <a:latin typeface="Segoe UI"/>
+              </a:rPr>
+              <a:t>• 4 scale-free funnel features; top feature: Impression volume vs median (92% of importance)</a:t>
+            </a:r>
+          </a:p>
+          <a:p>
+            <a:pPr algn="l"/>
+            <a:r>
+              <a:rPr sz="1150" b="0" i="0">
+                <a:solidFill>
+                  <a:srgbClr val="ECF1F9"/>
+                </a:solidFill>
+                <a:latin typeface="Segoe UI"/>
+              </a:rPr>
+              <a:t>• 5-fold CV deviance 0.11323 vs baseline 0.12147 (−6.79%): weak but measurable</a:t>
+            </a:r>
+          </a:p>
+          <a:p>
+            <a:pPr algn="l"/>
+            <a:r>
+              <a:rPr sz="1150" b="0" i="0">
+                <a:solidFill>
+                  <a:srgbClr val="ECF1F9"/>
+                </a:solidFill>
+                <a:latin typeface="Segoe UI"/>
+              </a:rPr>
+              <a:t>• Enters the engine as a multiplier of 0.85–1.15× at 35% weight</a:t>
+            </a:r>
+          </a:p>
+          <a:p>
+            <a:pPr algn="l"/>
+            <a:r>
+              <a:rPr sz="1150" b="0" i="0">
+                <a:solidFill>
+                  <a:srgbClr val="ECF1F9"/>
+                </a:solidFill>
+                <a:latin typeface="Segoe UI"/>
+              </a:rPr>
+              <a:t>• Margin, inventory, CAC, ROAS, risk and policy guardrails can override the raw signal</a:t>
+            </a:r>
+          </a:p>
+          <a:p>
+            <a:pPr algn="l"/>
+            <a:r>
+              <a:rPr sz="1150" b="0" i="0">
+                <a:solidFill>
+                  <a:srgbClr val="ECF1F9"/>
+                </a:solidFill>
+                <a:latin typeface="Segoe UI"/>
+              </a:rPr>
+              <a:t>• The system optimises incremental profit, not raw ROAS</a:t>
+            </a:r>
+          </a:p>
+        </p:txBody>
+      </p:sp>
+      <p:sp>
+        <p:nvSpPr>
+          <p:cNvPr id="11" name="Rounded Rectangle 10"/>
+          <p:cNvSpPr/>
+          <p:nvPr/>
+        </p:nvSpPr>
+        <p:spPr>
+          <a:xfrm>
+            <a:off x="6309360" y="1920240"/>
+            <a:ext cx="5303520" cy="4297680"/>
+          </a:xfrm>
+          <a:prstGeom prst="roundRect">
+            <a:avLst>
+              <a:gd name="adj" fmla="val 6000"/>
+            </a:avLst>
+          </a:prstGeom>
+          <a:solidFill>
+            <a:srgbClr val="121B2F"/>
+          </a:solidFill>
+          <a:ln>
+            <a:noFill/>
+          </a:ln>
+          <a:effectLst/>
+        </p:spPr>
+        <p:style>
+          <a:lnRef idx="1">
+            <a:schemeClr val="accent1"/>
+          </a:lnRef>
+          <a:fillRef idx="3">
+            <a:schemeClr val="accent1"/>
+          </a:fillRef>
+          <a:effectRef idx="2">
+            <a:schemeClr val="accent1"/>
+          </a:effectRef>
+          <a:fontRef idx="minor">
+            <a:schemeClr val="lt1"/>
+          </a:fontRef>
+        </p:style>
+        <p:txBody>
+          <a:bodyPr rtlCol="0" anchor="ctr"/>
+          <a:lstStyle/>
+          <a:p>
+            <a:pPr algn="ctr"/>
+          </a:p>
+        </p:txBody>
+      </p:sp>
+      <p:sp>
+        <p:nvSpPr>
+          <p:cNvPr id="12" name="TextBox 11"/>
+          <p:cNvSpPr txBox="1"/>
+          <p:nvPr/>
+        </p:nvSpPr>
+        <p:spPr>
+          <a:xfrm>
+            <a:off x="6537960" y="2057400"/>
+            <a:ext cx="4846320" cy="274320"/>
+          </a:xfrm>
+          <a:prstGeom prst="rect">
+            <a:avLst/>
+          </a:prstGeom>
+          <a:noFill/>
+        </p:spPr>
+        <p:txBody>
+          <a:bodyPr wrap="square" lIns="0" rIns="0" tIns="0" bIns="0" anchor="t">
+            <a:spAutoFit/>
+          </a:bodyPr>
+          <a:lstStyle/>
+          <a:p>
+            <a:pPr algn="l"/>
+            <a:r>
+              <a:rPr sz="1000" b="1" i="0">
+                <a:solidFill>
+                  <a:srgbClr val="F5B03A"/>
+                </a:solidFill>
+                <a:latin typeface="Segoe UI"/>
+              </a:rPr>
+              <a:t>DATA SOURCES (from sources.json)</a:t>
+            </a:r>
+          </a:p>
+        </p:txBody>
+      </p:sp>
+      <p:sp>
+        <p:nvSpPr>
+          <p:cNvPr id="13" name="TextBox 12"/>
+          <p:cNvSpPr txBox="1"/>
+          <p:nvPr/>
+        </p:nvSpPr>
+        <p:spPr>
+          <a:xfrm>
+            <a:off x="6537960" y="2423160"/>
+            <a:ext cx="4892040" cy="2743200"/>
+          </a:xfrm>
+          <a:prstGeom prst="rect">
+            <a:avLst/>
+          </a:prstGeom>
+          <a:noFill/>
+        </p:spPr>
+        <p:txBody>
+          <a:bodyPr wrap="square" lIns="0" rIns="0" tIns="0" bIns="0" anchor="t">
+            <a:spAutoFit/>
+          </a:bodyPr>
+          <a:lstStyle/>
+          <a:p>
+            <a:pPr algn="l"/>
+            <a:r>
+              <a:rPr sz="1000" b="0" i="0">
+                <a:solidFill>
+                  <a:srgbClr val="ECF1F9"/>
+                </a:solidFill>
+                <a:latin typeface="Segoe UI"/>
+              </a:rPr>
+              <a:t>• Adidas vs Nike (retail product listings) — CC0: Public Domain</a:t>
+            </a:r>
+          </a:p>
+          <a:p>
+            <a:pPr algn="l"/>
+            <a:r>
+              <a:rPr sz="1000" b="0" i="0">
+                <a:solidFill>
+                  <a:srgbClr val="ECF1F9"/>
+                </a:solidFill>
+                <a:latin typeface="Segoe UI"/>
+              </a:rPr>
+              <a:t>• Flipkart Mobile Dataset — CC0: Public Domain</a:t>
+            </a:r>
+          </a:p>
+          <a:p>
+            <a:pPr algn="l"/>
+            <a:r>
+              <a:rPr sz="1000" b="0" i="0">
+                <a:solidFill>
+                  <a:srgbClr val="ECF1F9"/>
+                </a:solidFill>
+                <a:latin typeface="Segoe UI"/>
+              </a:rPr>
+              <a:t>• Flipkart India Laptops under ₹75,000 — CC0: Public Domain</a:t>
+            </a:r>
+          </a:p>
+          <a:p>
+            <a:pPr algn="l"/>
+            <a:r>
+              <a:rPr sz="1000" b="0" i="0">
+                <a:solidFill>
+                  <a:srgbClr val="ECF1F9"/>
+                </a:solidFill>
+                <a:latin typeface="Segoe UI"/>
+              </a:rPr>
+              <a:t>• Louis Vuitton product price list — France (Data Boutique) — Unknown (stated 'unknown' on the dataset card — used here only for product names/prices context)</a:t>
+            </a:r>
+          </a:p>
+          <a:p>
+            <a:pPr algn="l"/>
+            <a:r>
+              <a:rPr sz="1000" b="0" i="0">
+                <a:solidFill>
+                  <a:srgbClr val="ECF1F9"/>
+                </a:solidFill>
+                <a:latin typeface="Segoe UI"/>
+              </a:rPr>
+              <a:t>• Sneakers &amp; Streetwear Sales (2022) — Apache 2.0</a:t>
+            </a:r>
+          </a:p>
+          <a:p>
+            <a:pPr algn="l"/>
+            <a:r>
+              <a:rPr sz="1000" b="0" i="0">
+                <a:solidFill>
+                  <a:srgbClr val="ECF1F9"/>
+                </a:solidFill>
+                <a:latin typeface="Segoe UI"/>
+              </a:rPr>
+              <a:t>• Sales Conversion Optimization (Facebook ad campaigns) — Other (specified in the Kaggle dataset description)</a:t>
+            </a:r>
+          </a:p>
+        </p:txBody>
+      </p:sp>
+      <p:sp>
+        <p:nvSpPr>
+          <p:cNvPr id="14" name="TextBox 13"/>
+          <p:cNvSpPr txBox="1"/>
+          <p:nvPr/>
+        </p:nvSpPr>
+        <p:spPr>
+          <a:xfrm>
+            <a:off x="6537960" y="5029200"/>
+            <a:ext cx="4892040" cy="1188720"/>
+          </a:xfrm>
+          <a:prstGeom prst="rect">
+            <a:avLst/>
+          </a:prstGeom>
+          <a:noFill/>
+        </p:spPr>
+        <p:txBody>
+          <a:bodyPr wrap="square" lIns="0" rIns="0" tIns="0" bIns="0" anchor="t">
+            <a:spAutoFit/>
+          </a:bodyPr>
+          <a:lstStyle/>
+          <a:p>
+            <a:pPr algn="l"/>
+            <a:r>
+              <a:rPr sz="1050" b="0" i="0">
+                <a:solidFill>
+                  <a:srgbClr val="8F9DB8"/>
+                </a:solidFill>
+                <a:latin typeface="Segoe UI"/>
+              </a:rPr>
+              <a:t>No brand ad-account data is used or claimed. Spend, clicks, orders, ROAS and CAC are simulated (derived from public product signals). Policies are demo assumptions, not company strategy.</a:t>
             </a:r>
           </a:p>
         </p:txBody>
@@ -11706,7 +12399,7 @@
                 </a:solidFill>
                 <a:latin typeface="Segoe UI"/>
               </a:rPr>
-              <a:t>2 / 12</a:t>
+              <a:t>2 / 13</a:t>
             </a:r>
           </a:p>
         </p:txBody>
@@ -11822,7 +12515,7 @@
                 </a:solidFill>
                 <a:latin typeface="Segoe UI"/>
               </a:rPr>
-              <a:t>ROAS ↓ 51%</a:t>
+              <a:t>ROAS ↓ 52%</a:t>
             </a:r>
           </a:p>
         </p:txBody>
@@ -11857,8 +12550,8 @@
                 </a:solidFill>
                 <a:latin typeface="Segoe UI"/>
               </a:rPr>
-              <a:t>Linen Blazer · Meta · Lookalike 1%
-6.0 → 3.0</a:t>
+              <a:t>Air Jordan 10 Retro · Meta · Lookalike 1%
+7.2 → 3.4</a:t>
             </a:r>
           </a:p>
         </p:txBody>
@@ -12637,7 +13330,7 @@
                 </a:solidFill>
                 <a:latin typeface="Segoe UI"/>
               </a:rPr>
-              <a:t>A luxury label and a perishable-food brand get the same ROAS goal.</a:t>
+              <a:t>A luxury label and a thin-margin hardware brand get the same ROAS goal.</a:t>
             </a:r>
           </a:p>
         </p:txBody>
@@ -13007,7 +13700,7 @@
                 </a:solidFill>
                 <a:latin typeface="Segoe UI"/>
               </a:rPr>
-              <a:t>3 / 12</a:t>
+              <a:t>3 / 13</a:t>
             </a:r>
           </a:p>
         </p:txBody>
@@ -14527,7 +15220,7 @@
                 </a:solidFill>
                 <a:latin typeface="Segoe UI"/>
               </a:rPr>
-              <a:t>4 / 12</a:t>
+              <a:t>4 / 13</a:t>
             </a:r>
           </a:p>
         </p:txBody>
@@ -15565,7 +16258,7 @@
                 </a:solidFill>
                 <a:latin typeface="Segoe UI"/>
               </a:rPr>
-              <a:t>21%</a:t>
+              <a:t>16%</a:t>
             </a:r>
           </a:p>
         </p:txBody>
@@ -15681,7 +16374,7 @@
                 </a:solidFill>
                 <a:latin typeface="Segoe UI"/>
               </a:rPr>
-              <a:t>5.5 → 4.6</a:t>
+              <a:t>6.5 → 5.6</a:t>
             </a:r>
           </a:p>
         </p:txBody>
@@ -15996,7 +16689,7 @@
                 </a:solidFill>
                 <a:latin typeface="Segoe UI"/>
               </a:rPr>
-              <a:t>5 / 12</a:t>
+              <a:t>5 / 13</a:t>
             </a:r>
           </a:p>
         </p:txBody>
@@ -16063,7 +16756,7 @@
         <p:spPr>
           <a:xfrm>
             <a:off x="594360" y="4956048"/>
-            <a:ext cx="5303520" cy="1371600"/>
+            <a:ext cx="5440680" cy="1371600"/>
           </a:xfrm>
           <a:prstGeom prst="roundRect">
             <a:avLst>
@@ -16108,8 +16801,8 @@
         </p:nvSpPr>
         <p:spPr>
           <a:xfrm>
-            <a:off x="731520" y="5029200"/>
-            <a:ext cx="1188720" cy="228600"/>
+            <a:off x="685800" y="5029200"/>
+            <a:ext cx="1097280" cy="228600"/>
           </a:xfrm>
           <a:prstGeom prst="rect">
             <a:avLst/>
@@ -16143,8 +16836,8 @@
         </p:nvSpPr>
         <p:spPr>
           <a:xfrm>
-            <a:off x="1965960" y="5029200"/>
-            <a:ext cx="960120" cy="228600"/>
+            <a:off x="1783080" y="5029200"/>
+            <a:ext cx="841248" cy="228600"/>
           </a:xfrm>
           <a:prstGeom prst="rect">
             <a:avLst/>
@@ -16165,7 +16858,7 @@
                 </a:solidFill>
                 <a:latin typeface="Segoe UI"/>
               </a:rPr>
-              <a:t>Fashion</a:t>
+              <a:t>Nike</a:t>
             </a:r>
           </a:p>
         </p:txBody>
@@ -16178,8 +16871,8 @@
         </p:nvSpPr>
         <p:spPr>
           <a:xfrm>
-            <a:off x="2971800" y="5029200"/>
-            <a:ext cx="960120" cy="228600"/>
+            <a:off x="2642615" y="5029200"/>
+            <a:ext cx="841248" cy="228600"/>
           </a:xfrm>
           <a:prstGeom prst="rect">
             <a:avLst/>
@@ -16200,7 +16893,7 @@
                 </a:solidFill>
                 <a:latin typeface="Segoe UI"/>
               </a:rPr>
-              <a:t>Startup</a:t>
+              <a:t>Samsung</a:t>
             </a:r>
           </a:p>
         </p:txBody>
@@ -16213,8 +16906,8 @@
         </p:nvSpPr>
         <p:spPr>
           <a:xfrm>
-            <a:off x="3977640" y="5029200"/>
-            <a:ext cx="960120" cy="228600"/>
+            <a:off x="3502152" y="5029200"/>
+            <a:ext cx="841248" cy="228600"/>
           </a:xfrm>
           <a:prstGeom prst="rect">
             <a:avLst/>
@@ -16235,7 +16928,7 @@
                 </a:solidFill>
                 <a:latin typeface="Segoe UI"/>
               </a:rPr>
-              <a:t>Electr.</a:t>
+              <a:t>Lenovo</a:t>
             </a:r>
           </a:p>
         </p:txBody>
@@ -16248,8 +16941,8 @@
         </p:nvSpPr>
         <p:spPr>
           <a:xfrm>
-            <a:off x="4983480" y="5029200"/>
-            <a:ext cx="960120" cy="228600"/>
+            <a:off x="4361688" y="5029200"/>
+            <a:ext cx="841248" cy="228600"/>
           </a:xfrm>
           <a:prstGeom prst="rect">
             <a:avLst/>
@@ -16270,7 +16963,7 @@
                 </a:solidFill>
                 <a:latin typeface="Segoe UI"/>
               </a:rPr>
-              <a:t>Food</a:t>
+              <a:t>LV</a:t>
             </a:r>
           </a:p>
         </p:txBody>
@@ -16283,8 +16976,43 @@
         </p:nvSpPr>
         <p:spPr>
           <a:xfrm>
-            <a:off x="731520" y="5289804"/>
-            <a:ext cx="1188720" cy="228600"/>
+            <a:off x="5221224" y="5029200"/>
+            <a:ext cx="841248" cy="228600"/>
+          </a:xfrm>
+          <a:prstGeom prst="rect">
+            <a:avLst/>
+          </a:prstGeom>
+          <a:noFill/>
+        </p:spPr>
+        <p:txBody>
+          <a:bodyPr wrap="square" lIns="0" rIns="0" tIns="0" bIns="0" anchor="t">
+            <a:spAutoFit/>
+          </a:bodyPr>
+          <a:lstStyle/>
+          <a:p>
+            <a:pPr algn="ctr"/>
+            <a:r>
+              <a:rPr sz="1000" b="1" i="0">
+                <a:solidFill>
+                  <a:srgbClr val="F5B03A"/>
+                </a:solidFill>
+                <a:latin typeface="Segoe UI"/>
+              </a:rPr>
+              <a:t>Supreme</a:t>
+            </a:r>
+          </a:p>
+        </p:txBody>
+      </p:sp>
+      <p:sp>
+        <p:nvSpPr>
+          <p:cNvPr id="17" name="TextBox 16"/>
+          <p:cNvSpPr txBox="1"/>
+          <p:nvPr/>
+        </p:nvSpPr>
+        <p:spPr>
+          <a:xfrm>
+            <a:off x="685800" y="5289804"/>
+            <a:ext cx="1097280" cy="228600"/>
           </a:xfrm>
           <a:prstGeom prst="rect">
             <a:avLst/>
@@ -16312,14 +17040,14 @@
       </p:sp>
       <p:sp>
         <p:nvSpPr>
-          <p:cNvPr id="17" name="TextBox 16"/>
-          <p:cNvSpPr txBox="1"/>
-          <p:nvPr/>
-        </p:nvSpPr>
-        <p:spPr>
-          <a:xfrm>
-            <a:off x="1965960" y="5289804"/>
-            <a:ext cx="960120" cy="228600"/>
+          <p:cNvPr id="18" name="TextBox 17"/>
+          <p:cNvSpPr txBox="1"/>
+          <p:nvPr/>
+        </p:nvSpPr>
+        <p:spPr>
+          <a:xfrm>
+            <a:off x="1783080" y="5289804"/>
+            <a:ext cx="841248" cy="228600"/>
           </a:xfrm>
           <a:prstGeom prst="rect">
             <a:avLst/>
@@ -16340,6 +17068,146 @@
                 </a:solidFill>
                 <a:latin typeface="Segoe UI"/>
               </a:rPr>
+              <a:t>35%</a:t>
+            </a:r>
+          </a:p>
+        </p:txBody>
+      </p:sp>
+      <p:sp>
+        <p:nvSpPr>
+          <p:cNvPr id="19" name="TextBox 18"/>
+          <p:cNvSpPr txBox="1"/>
+          <p:nvPr/>
+        </p:nvSpPr>
+        <p:spPr>
+          <a:xfrm>
+            <a:off x="2642615" y="5289804"/>
+            <a:ext cx="841248" cy="228600"/>
+          </a:xfrm>
+          <a:prstGeom prst="rect">
+            <a:avLst/>
+          </a:prstGeom>
+          <a:noFill/>
+        </p:spPr>
+        <p:txBody>
+          <a:bodyPr wrap="square" lIns="0" rIns="0" tIns="0" bIns="0" anchor="t">
+            <a:spAutoFit/>
+          </a:bodyPr>
+          <a:lstStyle/>
+          <a:p>
+            <a:pPr algn="ctr"/>
+            <a:r>
+              <a:rPr sz="1000" b="0" i="0">
+                <a:solidFill>
+                  <a:srgbClr val="ECF1F9"/>
+                </a:solidFill>
+                <a:latin typeface="Segoe UI"/>
+              </a:rPr>
+              <a:t>18%</a:t>
+            </a:r>
+          </a:p>
+        </p:txBody>
+      </p:sp>
+      <p:sp>
+        <p:nvSpPr>
+          <p:cNvPr id="20" name="TextBox 19"/>
+          <p:cNvSpPr txBox="1"/>
+          <p:nvPr/>
+        </p:nvSpPr>
+        <p:spPr>
+          <a:xfrm>
+            <a:off x="3502152" y="5289804"/>
+            <a:ext cx="841248" cy="228600"/>
+          </a:xfrm>
+          <a:prstGeom prst="rect">
+            <a:avLst/>
+          </a:prstGeom>
+          <a:noFill/>
+        </p:spPr>
+        <p:txBody>
+          <a:bodyPr wrap="square" lIns="0" rIns="0" tIns="0" bIns="0" anchor="t">
+            <a:spAutoFit/>
+          </a:bodyPr>
+          <a:lstStyle/>
+          <a:p>
+            <a:pPr algn="ctr"/>
+            <a:r>
+              <a:rPr sz="1000" b="0" i="0">
+                <a:solidFill>
+                  <a:srgbClr val="ECF1F9"/>
+                </a:solidFill>
+                <a:latin typeface="Segoe UI"/>
+              </a:rPr>
+              <a:t>12%</a:t>
+            </a:r>
+          </a:p>
+        </p:txBody>
+      </p:sp>
+      <p:sp>
+        <p:nvSpPr>
+          <p:cNvPr id="21" name="TextBox 20"/>
+          <p:cNvSpPr txBox="1"/>
+          <p:nvPr/>
+        </p:nvSpPr>
+        <p:spPr>
+          <a:xfrm>
+            <a:off x="4361688" y="5289804"/>
+            <a:ext cx="841248" cy="228600"/>
+          </a:xfrm>
+          <a:prstGeom prst="rect">
+            <a:avLst/>
+          </a:prstGeom>
+          <a:noFill/>
+        </p:spPr>
+        <p:txBody>
+          <a:bodyPr wrap="square" lIns="0" rIns="0" tIns="0" bIns="0" anchor="t">
+            <a:spAutoFit/>
+          </a:bodyPr>
+          <a:lstStyle/>
+          <a:p>
+            <a:pPr algn="ctr"/>
+            <a:r>
+              <a:rPr sz="1000" b="0" i="0">
+                <a:solidFill>
+                  <a:srgbClr val="ECF1F9"/>
+                </a:solidFill>
+                <a:latin typeface="Segoe UI"/>
+              </a:rPr>
+              <a:t>55%</a:t>
+            </a:r>
+          </a:p>
+        </p:txBody>
+      </p:sp>
+      <p:sp>
+        <p:nvSpPr>
+          <p:cNvPr id="22" name="TextBox 21"/>
+          <p:cNvSpPr txBox="1"/>
+          <p:nvPr/>
+        </p:nvSpPr>
+        <p:spPr>
+          <a:xfrm>
+            <a:off x="5221224" y="5289804"/>
+            <a:ext cx="841248" cy="228600"/>
+          </a:xfrm>
+          <a:prstGeom prst="rect">
+            <a:avLst/>
+          </a:prstGeom>
+          <a:noFill/>
+        </p:spPr>
+        <p:txBody>
+          <a:bodyPr wrap="square" lIns="0" rIns="0" tIns="0" bIns="0" anchor="t">
+            <a:spAutoFit/>
+          </a:bodyPr>
+          <a:lstStyle/>
+          <a:p>
+            <a:pPr algn="ctr"/>
+            <a:r>
+              <a:rPr sz="1000" b="0" i="0">
+                <a:solidFill>
+                  <a:srgbClr val="ECF1F9"/>
+                </a:solidFill>
+                <a:latin typeface="Segoe UI"/>
+              </a:rPr>
               <a:t>45%</a:t>
             </a:r>
           </a:p>
@@ -16347,14 +17215,49 @@
       </p:sp>
       <p:sp>
         <p:nvSpPr>
-          <p:cNvPr id="18" name="TextBox 17"/>
-          <p:cNvSpPr txBox="1"/>
-          <p:nvPr/>
-        </p:nvSpPr>
-        <p:spPr>
-          <a:xfrm>
-            <a:off x="2971800" y="5289804"/>
-            <a:ext cx="960120" cy="228600"/>
+          <p:cNvPr id="23" name="TextBox 22"/>
+          <p:cNvSpPr txBox="1"/>
+          <p:nvPr/>
+        </p:nvSpPr>
+        <p:spPr>
+          <a:xfrm>
+            <a:off x="685800" y="5550408"/>
+            <a:ext cx="1097280" cy="228600"/>
+          </a:xfrm>
+          <a:prstGeom prst="rect">
+            <a:avLst/>
+          </a:prstGeom>
+          <a:noFill/>
+        </p:spPr>
+        <p:txBody>
+          <a:bodyPr wrap="square" lIns="0" rIns="0" tIns="0" bIns="0" anchor="t">
+            <a:spAutoFit/>
+          </a:bodyPr>
+          <a:lstStyle/>
+          <a:p>
+            <a:pPr algn="l"/>
+            <a:r>
+              <a:rPr sz="1000" b="0" i="0">
+                <a:solidFill>
+                  <a:srgbClr val="8F9DB8"/>
+                </a:solidFill>
+                <a:latin typeface="Segoe UI"/>
+              </a:rPr>
+              <a:t>Min ROAS</a:t>
+            </a:r>
+          </a:p>
+        </p:txBody>
+      </p:sp>
+      <p:sp>
+        <p:nvSpPr>
+          <p:cNvPr id="24" name="TextBox 23"/>
+          <p:cNvSpPr txBox="1"/>
+          <p:nvPr/>
+        </p:nvSpPr>
+        <p:spPr>
+          <a:xfrm>
+            <a:off x="1783080" y="5550408"/>
+            <a:ext cx="841248" cy="228600"/>
           </a:xfrm>
           <a:prstGeom prst="rect">
             <a:avLst/>
@@ -16375,21 +17278,21 @@
                 </a:solidFill>
                 <a:latin typeface="Segoe UI"/>
               </a:rPr>
-              <a:t>30%</a:t>
-            </a:r>
-          </a:p>
-        </p:txBody>
-      </p:sp>
-      <p:sp>
-        <p:nvSpPr>
-          <p:cNvPr id="19" name="TextBox 18"/>
-          <p:cNvSpPr txBox="1"/>
-          <p:nvPr/>
-        </p:nvSpPr>
-        <p:spPr>
-          <a:xfrm>
-            <a:off x="3977640" y="5289804"/>
-            <a:ext cx="960120" cy="228600"/>
+              <a:t>3.0×</a:t>
+            </a:r>
+          </a:p>
+        </p:txBody>
+      </p:sp>
+      <p:sp>
+        <p:nvSpPr>
+          <p:cNvPr id="25" name="TextBox 24"/>
+          <p:cNvSpPr txBox="1"/>
+          <p:nvPr/>
+        </p:nvSpPr>
+        <p:spPr>
+          <a:xfrm>
+            <a:off x="2642615" y="5550408"/>
+            <a:ext cx="841248" cy="228600"/>
           </a:xfrm>
           <a:prstGeom prst="rect">
             <a:avLst/>
@@ -16410,21 +17313,21 @@
                 </a:solidFill>
                 <a:latin typeface="Segoe UI"/>
               </a:rPr>
-              <a:t>12%</a:t>
-            </a:r>
-          </a:p>
-        </p:txBody>
-      </p:sp>
-      <p:sp>
-        <p:nvSpPr>
-          <p:cNvPr id="20" name="TextBox 19"/>
-          <p:cNvSpPr txBox="1"/>
-          <p:nvPr/>
-        </p:nvSpPr>
-        <p:spPr>
-          <a:xfrm>
-            <a:off x="4983480" y="5289804"/>
-            <a:ext cx="960120" cy="228600"/>
+              <a:t>4.5×</a:t>
+            </a:r>
+          </a:p>
+        </p:txBody>
+      </p:sp>
+      <p:sp>
+        <p:nvSpPr>
+          <p:cNvPr id="26" name="TextBox 25"/>
+          <p:cNvSpPr txBox="1"/>
+          <p:nvPr/>
+        </p:nvSpPr>
+        <p:spPr>
+          <a:xfrm>
+            <a:off x="3502152" y="5550408"/>
+            <a:ext cx="841248" cy="228600"/>
           </a:xfrm>
           <a:prstGeom prst="rect">
             <a:avLst/>
@@ -16445,56 +17348,126 @@
                 </a:solidFill>
                 <a:latin typeface="Segoe UI"/>
               </a:rPr>
-              <a:t>30%</a:t>
-            </a:r>
-          </a:p>
-        </p:txBody>
-      </p:sp>
-      <p:sp>
-        <p:nvSpPr>
-          <p:cNvPr id="21" name="TextBox 20"/>
-          <p:cNvSpPr txBox="1"/>
-          <p:nvPr/>
-        </p:nvSpPr>
-        <p:spPr>
-          <a:xfrm>
-            <a:off x="731520" y="5550408"/>
-            <a:ext cx="1188720" cy="228600"/>
-          </a:xfrm>
-          <a:prstGeom prst="rect">
-            <a:avLst/>
-          </a:prstGeom>
-          <a:noFill/>
-        </p:spPr>
-        <p:txBody>
-          <a:bodyPr wrap="square" lIns="0" rIns="0" tIns="0" bIns="0" anchor="t">
-            <a:spAutoFit/>
-          </a:bodyPr>
-          <a:lstStyle/>
-          <a:p>
-            <a:pPr algn="l"/>
+              <a:t>6.0×</a:t>
+            </a:r>
+          </a:p>
+        </p:txBody>
+      </p:sp>
+      <p:sp>
+        <p:nvSpPr>
+          <p:cNvPr id="27" name="TextBox 26"/>
+          <p:cNvSpPr txBox="1"/>
+          <p:nvPr/>
+        </p:nvSpPr>
+        <p:spPr>
+          <a:xfrm>
+            <a:off x="4361688" y="5550408"/>
+            <a:ext cx="841248" cy="228600"/>
+          </a:xfrm>
+          <a:prstGeom prst="rect">
+            <a:avLst/>
+          </a:prstGeom>
+          <a:noFill/>
+        </p:spPr>
+        <p:txBody>
+          <a:bodyPr wrap="square" lIns="0" rIns="0" tIns="0" bIns="0" anchor="t">
+            <a:spAutoFit/>
+          </a:bodyPr>
+          <a:lstStyle/>
+          <a:p>
+            <a:pPr algn="ctr"/>
             <a:r>
               <a:rPr sz="1000" b="0" i="0">
                 <a:solidFill>
+                  <a:srgbClr val="ECF1F9"/>
+                </a:solidFill>
+                <a:latin typeface="Segoe UI"/>
+              </a:rPr>
+              <a:t>3.0×</a:t>
+            </a:r>
+          </a:p>
+        </p:txBody>
+      </p:sp>
+      <p:sp>
+        <p:nvSpPr>
+          <p:cNvPr id="28" name="TextBox 27"/>
+          <p:cNvSpPr txBox="1"/>
+          <p:nvPr/>
+        </p:nvSpPr>
+        <p:spPr>
+          <a:xfrm>
+            <a:off x="5221224" y="5550408"/>
+            <a:ext cx="841248" cy="228600"/>
+          </a:xfrm>
+          <a:prstGeom prst="rect">
+            <a:avLst/>
+          </a:prstGeom>
+          <a:noFill/>
+        </p:spPr>
+        <p:txBody>
+          <a:bodyPr wrap="square" lIns="0" rIns="0" tIns="0" bIns="0" anchor="t">
+            <a:spAutoFit/>
+          </a:bodyPr>
+          <a:lstStyle/>
+          <a:p>
+            <a:pPr algn="ctr"/>
+            <a:r>
+              <a:rPr sz="1000" b="0" i="0">
+                <a:solidFill>
+                  <a:srgbClr val="ECF1F9"/>
+                </a:solidFill>
+                <a:latin typeface="Segoe UI"/>
+              </a:rPr>
+              <a:t>3.0×</a:t>
+            </a:r>
+          </a:p>
+        </p:txBody>
+      </p:sp>
+      <p:sp>
+        <p:nvSpPr>
+          <p:cNvPr id="29" name="TextBox 28"/>
+          <p:cNvSpPr txBox="1"/>
+          <p:nvPr/>
+        </p:nvSpPr>
+        <p:spPr>
+          <a:xfrm>
+            <a:off x="685800" y="5811012"/>
+            <a:ext cx="1097280" cy="228600"/>
+          </a:xfrm>
+          <a:prstGeom prst="rect">
+            <a:avLst/>
+          </a:prstGeom>
+          <a:noFill/>
+        </p:spPr>
+        <p:txBody>
+          <a:bodyPr wrap="square" lIns="0" rIns="0" tIns="0" bIns="0" anchor="t">
+            <a:spAutoFit/>
+          </a:bodyPr>
+          <a:lstStyle/>
+          <a:p>
+            <a:pPr algn="l"/>
+            <a:r>
+              <a:rPr sz="1000" b="0" i="0">
+                <a:solidFill>
                   <a:srgbClr val="8F9DB8"/>
                 </a:solidFill>
                 <a:latin typeface="Segoe UI"/>
               </a:rPr>
-              <a:t>Min ROAS</a:t>
-            </a:r>
-          </a:p>
-        </p:txBody>
-      </p:sp>
-      <p:sp>
-        <p:nvSpPr>
-          <p:cNvPr id="22" name="TextBox 21"/>
-          <p:cNvSpPr txBox="1"/>
-          <p:nvPr/>
-        </p:nvSpPr>
-        <p:spPr>
-          <a:xfrm>
-            <a:off x="1965960" y="5550408"/>
-            <a:ext cx="960120" cy="228600"/>
+              <a:t>Max CAC</a:t>
+            </a:r>
+          </a:p>
+        </p:txBody>
+      </p:sp>
+      <p:sp>
+        <p:nvSpPr>
+          <p:cNvPr id="30" name="TextBox 29"/>
+          <p:cNvSpPr txBox="1"/>
+          <p:nvPr/>
+        </p:nvSpPr>
+        <p:spPr>
+          <a:xfrm>
+            <a:off x="1783080" y="5811012"/>
+            <a:ext cx="841248" cy="228600"/>
           </a:xfrm>
           <a:prstGeom prst="rect">
             <a:avLst/>
@@ -16515,21 +17488,21 @@
                 </a:solidFill>
                 <a:latin typeface="Segoe UI"/>
               </a:rPr>
-              <a:t>3.0×</a:t>
-            </a:r>
-          </a:p>
-        </p:txBody>
-      </p:sp>
-      <p:sp>
-        <p:nvSpPr>
-          <p:cNvPr id="23" name="TextBox 22"/>
-          <p:cNvSpPr txBox="1"/>
-          <p:nvPr/>
-        </p:nvSpPr>
-        <p:spPr>
-          <a:xfrm>
-            <a:off x="2971800" y="5550408"/>
-            <a:ext cx="960120" cy="228600"/>
+              <a:t>₹2.8k</a:t>
+            </a:r>
+          </a:p>
+        </p:txBody>
+      </p:sp>
+      <p:sp>
+        <p:nvSpPr>
+          <p:cNvPr id="31" name="TextBox 30"/>
+          <p:cNvSpPr txBox="1"/>
+          <p:nvPr/>
+        </p:nvSpPr>
+        <p:spPr>
+          <a:xfrm>
+            <a:off x="2642615" y="5811012"/>
+            <a:ext cx="841248" cy="228600"/>
           </a:xfrm>
           <a:prstGeom prst="rect">
             <a:avLst/>
@@ -16550,21 +17523,21 @@
                 </a:solidFill>
                 <a:latin typeface="Segoe UI"/>
               </a:rPr>
-              <a:t>1.8×</a:t>
-            </a:r>
-          </a:p>
-        </p:txBody>
-      </p:sp>
-      <p:sp>
-        <p:nvSpPr>
-          <p:cNvPr id="24" name="TextBox 23"/>
-          <p:cNvSpPr txBox="1"/>
-          <p:nvPr/>
-        </p:nvSpPr>
-        <p:spPr>
-          <a:xfrm>
-            <a:off x="3977640" y="5550408"/>
-            <a:ext cx="960120" cy="228600"/>
+              <a:t>₹3.2k</a:t>
+            </a:r>
+          </a:p>
+        </p:txBody>
+      </p:sp>
+      <p:sp>
+        <p:nvSpPr>
+          <p:cNvPr id="32" name="TextBox 31"/>
+          <p:cNvSpPr txBox="1"/>
+          <p:nvPr/>
+        </p:nvSpPr>
+        <p:spPr>
+          <a:xfrm>
+            <a:off x="3502152" y="5811012"/>
+            <a:ext cx="841248" cy="228600"/>
           </a:xfrm>
           <a:prstGeom prst="rect">
             <a:avLst/>
@@ -16585,21 +17558,21 @@
                 </a:solidFill>
                 <a:latin typeface="Segoe UI"/>
               </a:rPr>
-              <a:t>5.0×</a:t>
-            </a:r>
-          </a:p>
-        </p:txBody>
-      </p:sp>
-      <p:sp>
-        <p:nvSpPr>
-          <p:cNvPr id="25" name="TextBox 24"/>
-          <p:cNvSpPr txBox="1"/>
-          <p:nvPr/>
-        </p:nvSpPr>
-        <p:spPr>
-          <a:xfrm>
-            <a:off x="4983480" y="5550408"/>
-            <a:ext cx="960120" cy="228600"/>
+              <a:t>₹3.5k</a:t>
+            </a:r>
+          </a:p>
+        </p:txBody>
+      </p:sp>
+      <p:sp>
+        <p:nvSpPr>
+          <p:cNvPr id="33" name="TextBox 32"/>
+          <p:cNvSpPr txBox="1"/>
+          <p:nvPr/>
+        </p:nvSpPr>
+        <p:spPr>
+          <a:xfrm>
+            <a:off x="4361688" y="5811012"/>
+            <a:ext cx="841248" cy="228600"/>
           </a:xfrm>
           <a:prstGeom prst="rect">
             <a:avLst/>
@@ -16620,56 +17593,91 @@
                 </a:solidFill>
                 <a:latin typeface="Segoe UI"/>
               </a:rPr>
-              <a:t>3.0×</a:t>
-            </a:r>
-          </a:p>
-        </p:txBody>
-      </p:sp>
-      <p:sp>
-        <p:nvSpPr>
-          <p:cNvPr id="26" name="TextBox 25"/>
-          <p:cNvSpPr txBox="1"/>
-          <p:nvPr/>
-        </p:nvSpPr>
-        <p:spPr>
-          <a:xfrm>
-            <a:off x="731520" y="5811012"/>
-            <a:ext cx="1188720" cy="228600"/>
-          </a:xfrm>
-          <a:prstGeom prst="rect">
-            <a:avLst/>
-          </a:prstGeom>
-          <a:noFill/>
-        </p:spPr>
-        <p:txBody>
-          <a:bodyPr wrap="square" lIns="0" rIns="0" tIns="0" bIns="0" anchor="t">
-            <a:spAutoFit/>
-          </a:bodyPr>
-          <a:lstStyle/>
-          <a:p>
-            <a:pPr algn="l"/>
+              <a:t>₹45.0k</a:t>
+            </a:r>
+          </a:p>
+        </p:txBody>
+      </p:sp>
+      <p:sp>
+        <p:nvSpPr>
+          <p:cNvPr id="34" name="TextBox 33"/>
+          <p:cNvSpPr txBox="1"/>
+          <p:nvPr/>
+        </p:nvSpPr>
+        <p:spPr>
+          <a:xfrm>
+            <a:off x="5221224" y="5811012"/>
+            <a:ext cx="841248" cy="228600"/>
+          </a:xfrm>
+          <a:prstGeom prst="rect">
+            <a:avLst/>
+          </a:prstGeom>
+          <a:noFill/>
+        </p:spPr>
+        <p:txBody>
+          <a:bodyPr wrap="square" lIns="0" rIns="0" tIns="0" bIns="0" anchor="t">
+            <a:spAutoFit/>
+          </a:bodyPr>
+          <a:lstStyle/>
+          <a:p>
+            <a:pPr algn="ctr"/>
             <a:r>
               <a:rPr sz="1000" b="0" i="0">
                 <a:solidFill>
+                  <a:srgbClr val="ECF1F9"/>
+                </a:solidFill>
+                <a:latin typeface="Segoe UI"/>
+              </a:rPr>
+              <a:t>₹3.5k</a:t>
+            </a:r>
+          </a:p>
+        </p:txBody>
+      </p:sp>
+      <p:sp>
+        <p:nvSpPr>
+          <p:cNvPr id="35" name="TextBox 34"/>
+          <p:cNvSpPr txBox="1"/>
+          <p:nvPr/>
+        </p:nvSpPr>
+        <p:spPr>
+          <a:xfrm>
+            <a:off x="685800" y="6071616"/>
+            <a:ext cx="1097280" cy="228600"/>
+          </a:xfrm>
+          <a:prstGeom prst="rect">
+            <a:avLst/>
+          </a:prstGeom>
+          <a:noFill/>
+        </p:spPr>
+        <p:txBody>
+          <a:bodyPr wrap="square" lIns="0" rIns="0" tIns="0" bIns="0" anchor="t">
+            <a:spAutoFit/>
+          </a:bodyPr>
+          <a:lstStyle/>
+          <a:p>
+            <a:pPr algn="l"/>
+            <a:r>
+              <a:rPr sz="1000" b="0" i="0">
+                <a:solidFill>
                   <a:srgbClr val="8F9DB8"/>
                 </a:solidFill>
                 <a:latin typeface="Segoe UI"/>
               </a:rPr>
-              <a:t>Max CAC</a:t>
-            </a:r>
-          </a:p>
-        </p:txBody>
-      </p:sp>
-      <p:sp>
-        <p:nvSpPr>
-          <p:cNvPr id="27" name="TextBox 26"/>
-          <p:cNvSpPr txBox="1"/>
-          <p:nvPr/>
-        </p:nvSpPr>
-        <p:spPr>
-          <a:xfrm>
-            <a:off x="1965960" y="5811012"/>
-            <a:ext cx="960120" cy="228600"/>
+              <a:t>Stock target</a:t>
+            </a:r>
+          </a:p>
+        </p:txBody>
+      </p:sp>
+      <p:sp>
+        <p:nvSpPr>
+          <p:cNvPr id="36" name="TextBox 35"/>
+          <p:cNvSpPr txBox="1"/>
+          <p:nvPr/>
+        </p:nvSpPr>
+        <p:spPr>
+          <a:xfrm>
+            <a:off x="1783080" y="6071616"/>
+            <a:ext cx="841248" cy="228600"/>
           </a:xfrm>
           <a:prstGeom prst="rect">
             <a:avLst/>
@@ -16690,21 +17698,21 @@
                 </a:solidFill>
                 <a:latin typeface="Segoe UI"/>
               </a:rPr>
-              <a:t>₹2,200</a:t>
-            </a:r>
-          </a:p>
-        </p:txBody>
-      </p:sp>
-      <p:sp>
-        <p:nvSpPr>
-          <p:cNvPr id="28" name="TextBox 27"/>
-          <p:cNvSpPr txBox="1"/>
-          <p:nvPr/>
-        </p:nvSpPr>
-        <p:spPr>
-          <a:xfrm>
-            <a:off x="2971800" y="5811012"/>
-            <a:ext cx="960120" cy="228600"/>
+              <a:t>45 d</a:t>
+            </a:r>
+          </a:p>
+        </p:txBody>
+      </p:sp>
+      <p:sp>
+        <p:nvSpPr>
+          <p:cNvPr id="37" name="TextBox 36"/>
+          <p:cNvSpPr txBox="1"/>
+          <p:nvPr/>
+        </p:nvSpPr>
+        <p:spPr>
+          <a:xfrm>
+            <a:off x="2642615" y="6071616"/>
+            <a:ext cx="841248" cy="228600"/>
           </a:xfrm>
           <a:prstGeom prst="rect">
             <a:avLst/>
@@ -16725,21 +17733,21 @@
                 </a:solidFill>
                 <a:latin typeface="Segoe UI"/>
               </a:rPr>
-              <a:t>₹450</a:t>
-            </a:r>
-          </a:p>
-        </p:txBody>
-      </p:sp>
-      <p:sp>
-        <p:nvSpPr>
-          <p:cNvPr id="29" name="TextBox 28"/>
-          <p:cNvSpPr txBox="1"/>
-          <p:nvPr/>
-        </p:nvSpPr>
-        <p:spPr>
-          <a:xfrm>
-            <a:off x="3977640" y="5811012"/>
-            <a:ext cx="960120" cy="228600"/>
+              <a:t>35 d</a:t>
+            </a:r>
+          </a:p>
+        </p:txBody>
+      </p:sp>
+      <p:sp>
+        <p:nvSpPr>
+          <p:cNvPr id="38" name="TextBox 37"/>
+          <p:cNvSpPr txBox="1"/>
+          <p:nvPr/>
+        </p:nvSpPr>
+        <p:spPr>
+          <a:xfrm>
+            <a:off x="3502152" y="6071616"/>
+            <a:ext cx="841248" cy="228600"/>
           </a:xfrm>
           <a:prstGeom prst="rect">
             <a:avLst/>
@@ -16760,21 +17768,21 @@
                 </a:solidFill>
                 <a:latin typeface="Segoe UI"/>
               </a:rPr>
-              <a:t>₹1,200</a:t>
-            </a:r>
-          </a:p>
-        </p:txBody>
-      </p:sp>
-      <p:sp>
-        <p:nvSpPr>
-          <p:cNvPr id="30" name="TextBox 29"/>
-          <p:cNvSpPr txBox="1"/>
-          <p:nvPr/>
-        </p:nvSpPr>
-        <p:spPr>
-          <a:xfrm>
-            <a:off x="4983480" y="5811012"/>
-            <a:ext cx="960120" cy="228600"/>
+              <a:t>40 d</a:t>
+            </a:r>
+          </a:p>
+        </p:txBody>
+      </p:sp>
+      <p:sp>
+        <p:nvSpPr>
+          <p:cNvPr id="39" name="TextBox 38"/>
+          <p:cNvSpPr txBox="1"/>
+          <p:nvPr/>
+        </p:nvSpPr>
+        <p:spPr>
+          <a:xfrm>
+            <a:off x="4361688" y="6071616"/>
+            <a:ext cx="841248" cy="228600"/>
           </a:xfrm>
           <a:prstGeom prst="rect">
             <a:avLst/>
@@ -16795,189 +17803,49 @@
                 </a:solidFill>
                 <a:latin typeface="Segoe UI"/>
               </a:rPr>
-              <a:t>₹160</a:t>
-            </a:r>
-          </a:p>
-        </p:txBody>
-      </p:sp>
-      <p:sp>
-        <p:nvSpPr>
-          <p:cNvPr id="31" name="TextBox 30"/>
-          <p:cNvSpPr txBox="1"/>
-          <p:nvPr/>
-        </p:nvSpPr>
-        <p:spPr>
-          <a:xfrm>
-            <a:off x="731520" y="6071616"/>
-            <a:ext cx="1188720" cy="228600"/>
-          </a:xfrm>
-          <a:prstGeom prst="rect">
-            <a:avLst/>
-          </a:prstGeom>
-          <a:noFill/>
-        </p:spPr>
-        <p:txBody>
-          <a:bodyPr wrap="square" lIns="0" rIns="0" tIns="0" bIns="0" anchor="t">
-            <a:spAutoFit/>
-          </a:bodyPr>
-          <a:lstStyle/>
-          <a:p>
-            <a:pPr algn="l"/>
+              <a:t>60 d</a:t>
+            </a:r>
+          </a:p>
+        </p:txBody>
+      </p:sp>
+      <p:sp>
+        <p:nvSpPr>
+          <p:cNvPr id="40" name="TextBox 39"/>
+          <p:cNvSpPr txBox="1"/>
+          <p:nvPr/>
+        </p:nvSpPr>
+        <p:spPr>
+          <a:xfrm>
+            <a:off x="5221224" y="6071616"/>
+            <a:ext cx="841248" cy="228600"/>
+          </a:xfrm>
+          <a:prstGeom prst="rect">
+            <a:avLst/>
+          </a:prstGeom>
+          <a:noFill/>
+        </p:spPr>
+        <p:txBody>
+          <a:bodyPr wrap="square" lIns="0" rIns="0" tIns="0" bIns="0" anchor="t">
+            <a:spAutoFit/>
+          </a:bodyPr>
+          <a:lstStyle/>
+          <a:p>
+            <a:pPr algn="ctr"/>
             <a:r>
               <a:rPr sz="1000" b="0" i="0">
                 <a:solidFill>
-                  <a:srgbClr val="8F9DB8"/>
-                </a:solidFill>
-                <a:latin typeface="Segoe UI"/>
-              </a:rPr>
-              <a:t>Stock target</a:t>
-            </a:r>
-          </a:p>
-        </p:txBody>
-      </p:sp>
-      <p:sp>
-        <p:nvSpPr>
-          <p:cNvPr id="32" name="TextBox 31"/>
-          <p:cNvSpPr txBox="1"/>
-          <p:nvPr/>
-        </p:nvSpPr>
-        <p:spPr>
-          <a:xfrm>
-            <a:off x="1965960" y="6071616"/>
-            <a:ext cx="960120" cy="228600"/>
-          </a:xfrm>
-          <a:prstGeom prst="rect">
-            <a:avLst/>
-          </a:prstGeom>
-          <a:noFill/>
-        </p:spPr>
-        <p:txBody>
-          <a:bodyPr wrap="square" lIns="0" rIns="0" tIns="0" bIns="0" anchor="t">
-            <a:spAutoFit/>
-          </a:bodyPr>
-          <a:lstStyle/>
-          <a:p>
-            <a:pPr algn="ctr"/>
-            <a:r>
-              <a:rPr sz="1000" b="0" i="0">
-                <a:solidFill>
                   <a:srgbClr val="ECF1F9"/>
                 </a:solidFill>
                 <a:latin typeface="Segoe UI"/>
               </a:rPr>
-              <a:t>30 d</a:t>
-            </a:r>
-          </a:p>
-        </p:txBody>
-      </p:sp>
-      <p:sp>
-        <p:nvSpPr>
-          <p:cNvPr id="33" name="TextBox 32"/>
-          <p:cNvSpPr txBox="1"/>
-          <p:nvPr/>
-        </p:nvSpPr>
-        <p:spPr>
-          <a:xfrm>
-            <a:off x="2971800" y="6071616"/>
-            <a:ext cx="960120" cy="228600"/>
-          </a:xfrm>
-          <a:prstGeom prst="rect">
-            <a:avLst/>
-          </a:prstGeom>
-          <a:noFill/>
-        </p:spPr>
-        <p:txBody>
-          <a:bodyPr wrap="square" lIns="0" rIns="0" tIns="0" bIns="0" anchor="t">
-            <a:spAutoFit/>
-          </a:bodyPr>
-          <a:lstStyle/>
-          <a:p>
-            <a:pPr algn="ctr"/>
-            <a:r>
-              <a:rPr sz="1000" b="0" i="0">
-                <a:solidFill>
-                  <a:srgbClr val="ECF1F9"/>
-                </a:solidFill>
-                <a:latin typeface="Segoe UI"/>
-              </a:rPr>
-              <a:t>45 d</a:t>
-            </a:r>
-          </a:p>
-        </p:txBody>
-      </p:sp>
-      <p:sp>
-        <p:nvSpPr>
-          <p:cNvPr id="34" name="TextBox 33"/>
-          <p:cNvSpPr txBox="1"/>
-          <p:nvPr/>
-        </p:nvSpPr>
-        <p:spPr>
-          <a:xfrm>
-            <a:off x="3977640" y="6071616"/>
-            <a:ext cx="960120" cy="228600"/>
-          </a:xfrm>
-          <a:prstGeom prst="rect">
-            <a:avLst/>
-          </a:prstGeom>
-          <a:noFill/>
-        </p:spPr>
-        <p:txBody>
-          <a:bodyPr wrap="square" lIns="0" rIns="0" tIns="0" bIns="0" anchor="t">
-            <a:spAutoFit/>
-          </a:bodyPr>
-          <a:lstStyle/>
-          <a:p>
-            <a:pPr algn="ctr"/>
-            <a:r>
-              <a:rPr sz="1000" b="0" i="0">
-                <a:solidFill>
-                  <a:srgbClr val="ECF1F9"/>
-                </a:solidFill>
-                <a:latin typeface="Segoe UI"/>
-              </a:rPr>
-              <a:t>40 d</a:t>
-            </a:r>
-          </a:p>
-        </p:txBody>
-      </p:sp>
-      <p:sp>
-        <p:nvSpPr>
-          <p:cNvPr id="35" name="TextBox 34"/>
-          <p:cNvSpPr txBox="1"/>
-          <p:nvPr/>
-        </p:nvSpPr>
-        <p:spPr>
-          <a:xfrm>
-            <a:off x="4983480" y="6071616"/>
-            <a:ext cx="960120" cy="228600"/>
-          </a:xfrm>
-          <a:prstGeom prst="rect">
-            <a:avLst/>
-          </a:prstGeom>
-          <a:noFill/>
-        </p:spPr>
-        <p:txBody>
-          <a:bodyPr wrap="square" lIns="0" rIns="0" tIns="0" bIns="0" anchor="t">
-            <a:spAutoFit/>
-          </a:bodyPr>
-          <a:lstStyle/>
-          <a:p>
-            <a:pPr algn="ctr"/>
-            <a:r>
-              <a:rPr sz="1000" b="0" i="0">
-                <a:solidFill>
-                  <a:srgbClr val="ECF1F9"/>
-                </a:solidFill>
-                <a:latin typeface="Segoe UI"/>
-              </a:rPr>
-              <a:t>10 d</a:t>
-            </a:r>
-          </a:p>
-        </p:txBody>
-      </p:sp>
-      <p:sp>
-        <p:nvSpPr>
-          <p:cNvPr id="36" name="TextBox 35"/>
+              <a:t>14 d</a:t>
+            </a:r>
+          </a:p>
+        </p:txBody>
+      </p:sp>
+      <p:sp>
+        <p:nvSpPr>
+          <p:cNvPr id="41" name="TextBox 40"/>
           <p:cNvSpPr txBox="1"/>
           <p:nvPr/>
         </p:nvSpPr>
@@ -17005,21 +17873,21 @@
                 </a:solidFill>
                 <a:latin typeface="Segoe UI"/>
               </a:rPr>
-              <a:t>ONE FASHION CAMPAIGN SET · FOUR POLICIES · DAILY BUDGET CHANGE</a:t>
-            </a:r>
-          </a:p>
-        </p:txBody>
-      </p:sp>
-      <p:sp>
-        <p:nvSpPr>
-          <p:cNvPr id="37" name="TextBox 36"/>
-          <p:cNvSpPr txBox="1"/>
-          <p:nvPr/>
-        </p:nvSpPr>
-        <p:spPr>
-          <a:xfrm>
-            <a:off x="8229600" y="2194560"/>
-            <a:ext cx="822960" cy="274320"/>
+              <a:t>ONE NIKE CAMPAIGN SET · FIVE DEMO POLICIES · DAILY BUDGET CHANGE</a:t>
+            </a:r>
+          </a:p>
+        </p:txBody>
+      </p:sp>
+      <p:sp>
+        <p:nvSpPr>
+          <p:cNvPr id="42" name="TextBox 41"/>
+          <p:cNvSpPr txBox="1"/>
+          <p:nvPr/>
+        </p:nvSpPr>
+        <p:spPr>
+          <a:xfrm>
+            <a:off x="7589520" y="2194560"/>
+            <a:ext cx="786384" cy="274320"/>
           </a:xfrm>
           <a:prstGeom prst="rect">
             <a:avLst/>
@@ -17034,27 +17902,27 @@
           <a:p>
             <a:pPr algn="ctr"/>
             <a:r>
-              <a:rPr sz="1000" b="1" i="0">
+              <a:rPr sz="900" b="1" i="0">
                 <a:solidFill>
                   <a:srgbClr val="F5B03A"/>
                 </a:solidFill>
                 <a:latin typeface="Segoe UI"/>
               </a:rPr>
-              <a:t>Fashion</a:t>
-            </a:r>
-          </a:p>
-        </p:txBody>
-      </p:sp>
-      <p:sp>
-        <p:nvSpPr>
-          <p:cNvPr id="38" name="TextBox 37"/>
-          <p:cNvSpPr txBox="1"/>
-          <p:nvPr/>
-        </p:nvSpPr>
-        <p:spPr>
-          <a:xfrm>
-            <a:off x="9070848" y="2194560"/>
-            <a:ext cx="822960" cy="274320"/>
+              <a:t>Nike</a:t>
+            </a:r>
+          </a:p>
+        </p:txBody>
+      </p:sp>
+      <p:sp>
+        <p:nvSpPr>
+          <p:cNvPr id="43" name="TextBox 42"/>
+          <p:cNvSpPr txBox="1"/>
+          <p:nvPr/>
+        </p:nvSpPr>
+        <p:spPr>
+          <a:xfrm>
+            <a:off x="8394192" y="2194560"/>
+            <a:ext cx="786384" cy="274320"/>
           </a:xfrm>
           <a:prstGeom prst="rect">
             <a:avLst/>
@@ -17069,27 +17937,27 @@
           <a:p>
             <a:pPr algn="ctr"/>
             <a:r>
-              <a:rPr sz="1000" b="1" i="0">
+              <a:rPr sz="900" b="1" i="0">
                 <a:solidFill>
                   <a:srgbClr val="F5B03A"/>
                 </a:solidFill>
                 <a:latin typeface="Segoe UI"/>
               </a:rPr>
-              <a:t>Startup</a:t>
-            </a:r>
-          </a:p>
-        </p:txBody>
-      </p:sp>
-      <p:sp>
-        <p:nvSpPr>
-          <p:cNvPr id="39" name="TextBox 38"/>
-          <p:cNvSpPr txBox="1"/>
-          <p:nvPr/>
-        </p:nvSpPr>
-        <p:spPr>
-          <a:xfrm>
-            <a:off x="9912096" y="2194560"/>
-            <a:ext cx="822960" cy="274320"/>
+              <a:t>Samsung</a:t>
+            </a:r>
+          </a:p>
+        </p:txBody>
+      </p:sp>
+      <p:sp>
+        <p:nvSpPr>
+          <p:cNvPr id="44" name="TextBox 43"/>
+          <p:cNvSpPr txBox="1"/>
+          <p:nvPr/>
+        </p:nvSpPr>
+        <p:spPr>
+          <a:xfrm>
+            <a:off x="9198864" y="2194560"/>
+            <a:ext cx="786384" cy="274320"/>
           </a:xfrm>
           <a:prstGeom prst="rect">
             <a:avLst/>
@@ -17104,27 +17972,27 @@
           <a:p>
             <a:pPr algn="ctr"/>
             <a:r>
-              <a:rPr sz="1000" b="1" i="0">
+              <a:rPr sz="900" b="1" i="0">
                 <a:solidFill>
                   <a:srgbClr val="F5B03A"/>
                 </a:solidFill>
                 <a:latin typeface="Segoe UI"/>
               </a:rPr>
-              <a:t>Electr.</a:t>
-            </a:r>
-          </a:p>
-        </p:txBody>
-      </p:sp>
-      <p:sp>
-        <p:nvSpPr>
-          <p:cNvPr id="40" name="TextBox 39"/>
-          <p:cNvSpPr txBox="1"/>
-          <p:nvPr/>
-        </p:nvSpPr>
-        <p:spPr>
-          <a:xfrm>
-            <a:off x="10753344" y="2194560"/>
-            <a:ext cx="822960" cy="274320"/>
+              <a:t>Lenovo</a:t>
+            </a:r>
+          </a:p>
+        </p:txBody>
+      </p:sp>
+      <p:sp>
+        <p:nvSpPr>
+          <p:cNvPr id="45" name="TextBox 44"/>
+          <p:cNvSpPr txBox="1"/>
+          <p:nvPr/>
+        </p:nvSpPr>
+        <p:spPr>
+          <a:xfrm>
+            <a:off x="10003536" y="2194560"/>
+            <a:ext cx="786384" cy="274320"/>
           </a:xfrm>
           <a:prstGeom prst="rect">
             <a:avLst/>
@@ -17139,20 +18007,55 @@
           <a:p>
             <a:pPr algn="ctr"/>
             <a:r>
-              <a:rPr sz="1000" b="1" i="0">
+              <a:rPr sz="900" b="1" i="0">
                 <a:solidFill>
                   <a:srgbClr val="F5B03A"/>
                 </a:solidFill>
                 <a:latin typeface="Segoe UI"/>
               </a:rPr>
-              <a:t>Food</a:t>
-            </a:r>
-          </a:p>
-        </p:txBody>
-      </p:sp>
-      <p:sp>
-        <p:nvSpPr>
-          <p:cNvPr id="41" name="Rounded Rectangle 40"/>
+              <a:t>LV</a:t>
+            </a:r>
+          </a:p>
+        </p:txBody>
+      </p:sp>
+      <p:sp>
+        <p:nvSpPr>
+          <p:cNvPr id="46" name="TextBox 45"/>
+          <p:cNvSpPr txBox="1"/>
+          <p:nvPr/>
+        </p:nvSpPr>
+        <p:spPr>
+          <a:xfrm>
+            <a:off x="10808208" y="2194560"/>
+            <a:ext cx="786384" cy="274320"/>
+          </a:xfrm>
+          <a:prstGeom prst="rect">
+            <a:avLst/>
+          </a:prstGeom>
+          <a:noFill/>
+        </p:spPr>
+        <p:txBody>
+          <a:bodyPr wrap="square" lIns="0" rIns="0" tIns="0" bIns="0" anchor="t">
+            <a:spAutoFit/>
+          </a:bodyPr>
+          <a:lstStyle/>
+          <a:p>
+            <a:pPr algn="ctr"/>
+            <a:r>
+              <a:rPr sz="900" b="1" i="0">
+                <a:solidFill>
+                  <a:srgbClr val="F5B03A"/>
+                </a:solidFill>
+                <a:latin typeface="Segoe UI"/>
+              </a:rPr>
+              <a:t>Supreme</a:t>
+            </a:r>
+          </a:p>
+        </p:txBody>
+      </p:sp>
+      <p:sp>
+        <p:nvSpPr>
+          <p:cNvPr id="47" name="Rounded Rectangle 46"/>
           <p:cNvSpPr/>
           <p:nvPr/>
         </p:nvSpPr>
@@ -17198,49 +18101,49 @@
       </p:sp>
       <p:sp>
         <p:nvSpPr>
-          <p:cNvPr id="42" name="TextBox 41"/>
-          <p:cNvSpPr txBox="1"/>
-          <p:nvPr/>
-        </p:nvSpPr>
-        <p:spPr>
-          <a:xfrm>
-            <a:off x="6446520" y="2660903"/>
-            <a:ext cx="1783080" cy="502920"/>
-          </a:xfrm>
-          <a:prstGeom prst="rect">
-            <a:avLst/>
-          </a:prstGeom>
-          <a:noFill/>
-        </p:spPr>
-        <p:txBody>
-          <a:bodyPr wrap="square" lIns="0" rIns="0" tIns="0" bIns="0" anchor="t">
-            <a:spAutoFit/>
-          </a:bodyPr>
-          <a:lstStyle/>
-          <a:p>
-            <a:pPr algn="l"/>
-            <a:r>
-              <a:rPr sz="1000" b="1" i="0">
+          <p:cNvPr id="48" name="TextBox 47"/>
+          <p:cNvSpPr txBox="1"/>
+          <p:nvPr/>
+        </p:nvSpPr>
+        <p:spPr>
+          <a:xfrm>
+            <a:off x="6400800" y="2633472"/>
+            <a:ext cx="1188720" cy="548640"/>
+          </a:xfrm>
+          <a:prstGeom prst="rect">
+            <a:avLst/>
+          </a:prstGeom>
+          <a:noFill/>
+        </p:spPr>
+        <p:txBody>
+          <a:bodyPr wrap="square" lIns="0" rIns="0" tIns="0" bIns="0" anchor="t">
+            <a:spAutoFit/>
+          </a:bodyPr>
+          <a:lstStyle/>
+          <a:p>
+            <a:pPr algn="l"/>
+            <a:r>
+              <a:rPr sz="850" b="1" i="0">
                 <a:solidFill>
                   <a:srgbClr val="ECF1F9"/>
                 </a:solidFill>
                 <a:latin typeface="Segoe UI"/>
               </a:rPr>
-              <a:t>Linen Blazer·Google·RT</a:t>
-            </a:r>
-          </a:p>
-        </p:txBody>
-      </p:sp>
-      <p:sp>
-        <p:nvSpPr>
-          <p:cNvPr id="43" name="Rounded Rectangle 42"/>
+              <a:t>Nike Zoom Fly·Google·Interest</a:t>
+            </a:r>
+          </a:p>
+        </p:txBody>
+      </p:sp>
+      <p:sp>
+        <p:nvSpPr>
+          <p:cNvPr id="49" name="Rounded Rectangle 48"/>
           <p:cNvSpPr/>
           <p:nvPr/>
         </p:nvSpPr>
         <p:spPr>
           <a:xfrm>
-            <a:off x="8247888" y="2734056"/>
-            <a:ext cx="749808" cy="310896"/>
+            <a:off x="7607808" y="2734056"/>
+            <a:ext cx="731520" cy="310896"/>
           </a:xfrm>
           <a:prstGeom prst="roundRect">
             <a:avLst>
@@ -17275,27 +18178,27 @@
           <a:p>
             <a:pPr algn="ctr"/>
             <a:r>
-              <a:rPr sz="1000" b="1">
+              <a:rPr sz="900" b="1">
                 <a:solidFill>
                   <a:srgbClr val="2DD4BF"/>
                 </a:solidFill>
                 <a:latin typeface="Segoe UI"/>
               </a:rPr>
-              <a:t>+₹7k</a:t>
-            </a:r>
-          </a:p>
-        </p:txBody>
-      </p:sp>
-      <p:sp>
-        <p:nvSpPr>
-          <p:cNvPr id="44" name="Rounded Rectangle 43"/>
+              <a:t>+₹22k</a:t>
+            </a:r>
+          </a:p>
+        </p:txBody>
+      </p:sp>
+      <p:sp>
+        <p:nvSpPr>
+          <p:cNvPr id="50" name="Rounded Rectangle 49"/>
           <p:cNvSpPr/>
           <p:nvPr/>
         </p:nvSpPr>
         <p:spPr>
           <a:xfrm>
-            <a:off x="9089136" y="2734056"/>
-            <a:ext cx="749808" cy="310896"/>
+            <a:off x="8412480" y="2734056"/>
+            <a:ext cx="731520" cy="310896"/>
           </a:xfrm>
           <a:prstGeom prst="roundRect">
             <a:avLst>
@@ -17330,7 +18233,7 @@
           <a:p>
             <a:pPr algn="ctr"/>
             <a:r>
-              <a:rPr sz="1000" b="1">
+              <a:rPr sz="900" b="1">
                 <a:solidFill>
                   <a:srgbClr val="8F9DB8"/>
                 </a:solidFill>
@@ -17343,14 +18246,14 @@
       </p:sp>
       <p:sp>
         <p:nvSpPr>
-          <p:cNvPr id="45" name="Rounded Rectangle 44"/>
+          <p:cNvPr id="51" name="Rounded Rectangle 50"/>
           <p:cNvSpPr/>
           <p:nvPr/>
         </p:nvSpPr>
         <p:spPr>
           <a:xfrm>
-            <a:off x="9930384" y="2734056"/>
-            <a:ext cx="749808" cy="310896"/>
+            <a:off x="9217152" y="2734056"/>
+            <a:ext cx="731520" cy="310896"/>
           </a:xfrm>
           <a:prstGeom prst="roundRect">
             <a:avLst>
@@ -17385,7 +18288,7 @@
           <a:p>
             <a:pPr algn="ctr"/>
             <a:r>
-              <a:rPr sz="1000" b="1">
+              <a:rPr sz="900" b="1">
                 <a:solidFill>
                   <a:srgbClr val="8F9DB8"/>
                 </a:solidFill>
@@ -17398,14 +18301,14 @@
       </p:sp>
       <p:sp>
         <p:nvSpPr>
-          <p:cNvPr id="46" name="Rounded Rectangle 45"/>
+          <p:cNvPr id="52" name="Rounded Rectangle 51"/>
           <p:cNvSpPr/>
           <p:nvPr/>
         </p:nvSpPr>
         <p:spPr>
           <a:xfrm>
-            <a:off x="10771632" y="2734056"/>
-            <a:ext cx="749808" cy="310896"/>
+            <a:off x="10021824" y="2734056"/>
+            <a:ext cx="731520" cy="310896"/>
           </a:xfrm>
           <a:prstGeom prst="roundRect">
             <a:avLst>
@@ -17440,20 +18343,75 @@
           <a:p>
             <a:pPr algn="ctr"/>
             <a:r>
-              <a:rPr sz="1000" b="1">
+              <a:rPr sz="900" b="1">
+                <a:solidFill>
+                  <a:srgbClr val="8F9DB8"/>
+                </a:solidFill>
+                <a:latin typeface="Segoe UI"/>
+              </a:rPr>
+              <a:t>hold</a:t>
+            </a:r>
+          </a:p>
+        </p:txBody>
+      </p:sp>
+      <p:sp>
+        <p:nvSpPr>
+          <p:cNvPr id="53" name="Rounded Rectangle 52"/>
+          <p:cNvSpPr/>
+          <p:nvPr/>
+        </p:nvSpPr>
+        <p:spPr>
+          <a:xfrm>
+            <a:off x="10826496" y="2734056"/>
+            <a:ext cx="731520" cy="310896"/>
+          </a:xfrm>
+          <a:prstGeom prst="roundRect">
+            <a:avLst>
+              <a:gd name="adj" fmla="val 50000"/>
+            </a:avLst>
+          </a:prstGeom>
+          <a:solidFill>
+            <a:srgbClr val="1A253D"/>
+          </a:solidFill>
+          <a:ln>
+            <a:noFill/>
+          </a:ln>
+          <a:effectLst/>
+        </p:spPr>
+        <p:style>
+          <a:lnRef idx="1">
+            <a:schemeClr val="accent1"/>
+          </a:lnRef>
+          <a:fillRef idx="3">
+            <a:schemeClr val="accent1"/>
+          </a:fillRef>
+          <a:effectRef idx="2">
+            <a:schemeClr val="accent1"/>
+          </a:effectRef>
+          <a:fontRef idx="minor">
+            <a:schemeClr val="lt1"/>
+          </a:fontRef>
+        </p:style>
+        <p:txBody>
+          <a:bodyPr rtlCol="0" anchor="ctr" lIns="45720" rIns="45720" tIns="0" bIns="0"/>
+          <a:lstStyle/>
+          <a:p>
+            <a:pPr algn="ctr"/>
+            <a:r>
+              <a:rPr sz="900" b="1">
                 <a:solidFill>
                   <a:srgbClr val="2DD4BF"/>
                 </a:solidFill>
                 <a:latin typeface="Segoe UI"/>
               </a:rPr>
-              <a:t>+₹5k</a:t>
-            </a:r>
-          </a:p>
-        </p:txBody>
-      </p:sp>
-      <p:sp>
-        <p:nvSpPr>
-          <p:cNvPr id="47" name="Rounded Rectangle 46"/>
+              <a:t>+₹22k</a:t>
+            </a:r>
+          </a:p>
+        </p:txBody>
+      </p:sp>
+      <p:sp>
+        <p:nvSpPr>
+          <p:cNvPr id="54" name="Rounded Rectangle 53"/>
           <p:cNvSpPr/>
           <p:nvPr/>
         </p:nvSpPr>
@@ -17499,49 +18457,49 @@
       </p:sp>
       <p:sp>
         <p:nvSpPr>
-          <p:cNvPr id="48" name="TextBox 47"/>
-          <p:cNvSpPr txBox="1"/>
-          <p:nvPr/>
-        </p:nvSpPr>
-        <p:spPr>
-          <a:xfrm>
-            <a:off x="6446520" y="3374135"/>
-            <a:ext cx="1783080" cy="502920"/>
-          </a:xfrm>
-          <a:prstGeom prst="rect">
-            <a:avLst/>
-          </a:prstGeom>
-          <a:noFill/>
-        </p:spPr>
-        <p:txBody>
-          <a:bodyPr wrap="square" lIns="0" rIns="0" tIns="0" bIns="0" anchor="t">
-            <a:spAutoFit/>
-          </a:bodyPr>
-          <a:lstStyle/>
-          <a:p>
-            <a:pPr algn="l"/>
-            <a:r>
-              <a:rPr sz="1000" b="1" i="0">
+          <p:cNvPr id="55" name="TextBox 54"/>
+          <p:cNvSpPr txBox="1"/>
+          <p:nvPr/>
+        </p:nvSpPr>
+        <p:spPr>
+          <a:xfrm>
+            <a:off x="6400800" y="3346703"/>
+            <a:ext cx="1188720" cy="548640"/>
+          </a:xfrm>
+          <a:prstGeom prst="rect">
+            <a:avLst/>
+          </a:prstGeom>
+          <a:noFill/>
+        </p:spPr>
+        <p:txBody>
+          <a:bodyPr wrap="square" lIns="0" rIns="0" tIns="0" bIns="0" anchor="t">
+            <a:spAutoFit/>
+          </a:bodyPr>
+          <a:lstStyle/>
+          <a:p>
+            <a:pPr algn="l"/>
+            <a:r>
+              <a:rPr sz="850" b="1" i="0">
                 <a:solidFill>
                   <a:srgbClr val="ECF1F9"/>
                 </a:solidFill>
                 <a:latin typeface="Segoe UI"/>
               </a:rPr>
-              <a:t>Silk Scarf·Instagram·LAL</a:t>
-            </a:r>
-          </a:p>
-        </p:txBody>
-      </p:sp>
-      <p:sp>
-        <p:nvSpPr>
-          <p:cNvPr id="49" name="Rounded Rectangle 48"/>
+              <a:t>Nike Epic React Flyknit 2·Google·Interest</a:t>
+            </a:r>
+          </a:p>
+        </p:txBody>
+      </p:sp>
+      <p:sp>
+        <p:nvSpPr>
+          <p:cNvPr id="56" name="Rounded Rectangle 55"/>
           <p:cNvSpPr/>
           <p:nvPr/>
         </p:nvSpPr>
         <p:spPr>
           <a:xfrm>
-            <a:off x="8247888" y="3447287"/>
-            <a:ext cx="749808" cy="310896"/>
+            <a:off x="7607808" y="3447287"/>
+            <a:ext cx="731520" cy="310896"/>
           </a:xfrm>
           <a:prstGeom prst="roundRect">
             <a:avLst>
@@ -17576,7 +18534,7 @@
           <a:p>
             <a:pPr algn="ctr"/>
             <a:r>
-              <a:rPr sz="1000" b="1">
+              <a:rPr sz="900" b="1">
                 <a:solidFill>
                   <a:srgbClr val="8F9DB8"/>
                 </a:solidFill>
@@ -17589,14 +18547,14 @@
       </p:sp>
       <p:sp>
         <p:nvSpPr>
-          <p:cNvPr id="50" name="Rounded Rectangle 49"/>
+          <p:cNvPr id="57" name="Rounded Rectangle 56"/>
           <p:cNvSpPr/>
           <p:nvPr/>
         </p:nvSpPr>
         <p:spPr>
           <a:xfrm>
-            <a:off x="9089136" y="3447287"/>
-            <a:ext cx="749808" cy="310896"/>
+            <a:off x="8412480" y="3447287"/>
+            <a:ext cx="731520" cy="310896"/>
           </a:xfrm>
           <a:prstGeom prst="roundRect">
             <a:avLst>
@@ -17631,27 +18589,27 @@
           <a:p>
             <a:pPr algn="ctr"/>
             <a:r>
-              <a:rPr sz="1000" b="1">
-                <a:solidFill>
-                  <a:srgbClr val="2DD4BF"/>
-                </a:solidFill>
-                <a:latin typeface="Segoe UI"/>
-              </a:rPr>
-              <a:t>+₹9k</a:t>
-            </a:r>
-          </a:p>
-        </p:txBody>
-      </p:sp>
-      <p:sp>
-        <p:nvSpPr>
-          <p:cNvPr id="51" name="Rounded Rectangle 50"/>
+              <a:rPr sz="900" b="1">
+                <a:solidFill>
+                  <a:srgbClr val="8F9DB8"/>
+                </a:solidFill>
+                <a:latin typeface="Segoe UI"/>
+              </a:rPr>
+              <a:t>hold</a:t>
+            </a:r>
+          </a:p>
+        </p:txBody>
+      </p:sp>
+      <p:sp>
+        <p:nvSpPr>
+          <p:cNvPr id="58" name="Rounded Rectangle 57"/>
           <p:cNvSpPr/>
           <p:nvPr/>
         </p:nvSpPr>
         <p:spPr>
           <a:xfrm>
-            <a:off x="9930384" y="3447287"/>
-            <a:ext cx="749808" cy="310896"/>
+            <a:off x="9217152" y="3447287"/>
+            <a:ext cx="731520" cy="310896"/>
           </a:xfrm>
           <a:prstGeom prst="roundRect">
             <a:avLst>
@@ -17686,7 +18644,7 @@
           <a:p>
             <a:pPr algn="ctr"/>
             <a:r>
-              <a:rPr sz="1000" b="1">
+              <a:rPr sz="900" b="1">
                 <a:solidFill>
                   <a:srgbClr val="8F9DB8"/>
                 </a:solidFill>
@@ -17699,14 +18657,14 @@
       </p:sp>
       <p:sp>
         <p:nvSpPr>
-          <p:cNvPr id="52" name="Rounded Rectangle 51"/>
+          <p:cNvPr id="59" name="Rounded Rectangle 58"/>
           <p:cNvSpPr/>
           <p:nvPr/>
         </p:nvSpPr>
         <p:spPr>
           <a:xfrm>
-            <a:off x="10771632" y="3447287"/>
-            <a:ext cx="749808" cy="310896"/>
+            <a:off x="10021824" y="3447287"/>
+            <a:ext cx="731520" cy="310896"/>
           </a:xfrm>
           <a:prstGeom prst="roundRect">
             <a:avLst>
@@ -17741,20 +18699,75 @@
           <a:p>
             <a:pPr algn="ctr"/>
             <a:r>
-              <a:rPr sz="1000" b="1">
-                <a:solidFill>
-                  <a:srgbClr val="8F9DB8"/>
-                </a:solidFill>
-                <a:latin typeface="Segoe UI"/>
-              </a:rPr>
-              <a:t>hold</a:t>
-            </a:r>
-          </a:p>
-        </p:txBody>
-      </p:sp>
-      <p:sp>
-        <p:nvSpPr>
-          <p:cNvPr id="53" name="Rounded Rectangle 52"/>
+              <a:rPr sz="900" b="1">
+                <a:solidFill>
+                  <a:srgbClr val="F87171"/>
+                </a:solidFill>
+                <a:latin typeface="Segoe UI"/>
+              </a:rPr>
+              <a:t>PAUSE</a:t>
+            </a:r>
+          </a:p>
+        </p:txBody>
+      </p:sp>
+      <p:sp>
+        <p:nvSpPr>
+          <p:cNvPr id="60" name="Rounded Rectangle 59"/>
+          <p:cNvSpPr/>
+          <p:nvPr/>
+        </p:nvSpPr>
+        <p:spPr>
+          <a:xfrm>
+            <a:off x="10826496" y="3447287"/>
+            <a:ext cx="731520" cy="310896"/>
+          </a:xfrm>
+          <a:prstGeom prst="roundRect">
+            <a:avLst>
+              <a:gd name="adj" fmla="val 50000"/>
+            </a:avLst>
+          </a:prstGeom>
+          <a:solidFill>
+            <a:srgbClr val="1A253D"/>
+          </a:solidFill>
+          <a:ln>
+            <a:noFill/>
+          </a:ln>
+          <a:effectLst/>
+        </p:spPr>
+        <p:style>
+          <a:lnRef idx="1">
+            <a:schemeClr val="accent1"/>
+          </a:lnRef>
+          <a:fillRef idx="3">
+            <a:schemeClr val="accent1"/>
+          </a:fillRef>
+          <a:effectRef idx="2">
+            <a:schemeClr val="accent1"/>
+          </a:effectRef>
+          <a:fontRef idx="minor">
+            <a:schemeClr val="lt1"/>
+          </a:fontRef>
+        </p:style>
+        <p:txBody>
+          <a:bodyPr rtlCol="0" anchor="ctr" lIns="45720" rIns="45720" tIns="0" bIns="0"/>
+          <a:lstStyle/>
+          <a:p>
+            <a:pPr algn="ctr"/>
+            <a:r>
+              <a:rPr sz="900" b="1">
+                <a:solidFill>
+                  <a:srgbClr val="F87171"/>
+                </a:solidFill>
+                <a:latin typeface="Segoe UI"/>
+              </a:rPr>
+              <a:t>PAUSE</a:t>
+            </a:r>
+          </a:p>
+        </p:txBody>
+      </p:sp>
+      <p:sp>
+        <p:nvSpPr>
+          <p:cNvPr id="61" name="Rounded Rectangle 60"/>
           <p:cNvSpPr/>
           <p:nvPr/>
         </p:nvSpPr>
@@ -17800,49 +18813,49 @@
       </p:sp>
       <p:sp>
         <p:nvSpPr>
-          <p:cNvPr id="54" name="TextBox 53"/>
-          <p:cNvSpPr txBox="1"/>
-          <p:nvPr/>
-        </p:nvSpPr>
-        <p:spPr>
-          <a:xfrm>
-            <a:off x="6446520" y="4087368"/>
-            <a:ext cx="1783080" cy="502920"/>
-          </a:xfrm>
-          <a:prstGeom prst="rect">
-            <a:avLst/>
-          </a:prstGeom>
-          <a:noFill/>
-        </p:spPr>
-        <p:txBody>
-          <a:bodyPr wrap="square" lIns="0" rIns="0" tIns="0" bIns="0" anchor="t">
-            <a:spAutoFit/>
-          </a:bodyPr>
-          <a:lstStyle/>
-          <a:p>
-            <a:pPr algn="l"/>
-            <a:r>
-              <a:rPr sz="1000" b="1" i="0">
+          <p:cNvPr id="62" name="TextBox 61"/>
+          <p:cNvSpPr txBox="1"/>
+          <p:nvPr/>
+        </p:nvSpPr>
+        <p:spPr>
+          <a:xfrm>
+            <a:off x="6400800" y="4059935"/>
+            <a:ext cx="1188720" cy="548640"/>
+          </a:xfrm>
+          <a:prstGeom prst="rect">
+            <a:avLst/>
+          </a:prstGeom>
+          <a:noFill/>
+        </p:spPr>
+        <p:txBody>
+          <a:bodyPr wrap="square" lIns="0" rIns="0" tIns="0" bIns="0" anchor="t">
+            <a:spAutoFit/>
+          </a:bodyPr>
+          <a:lstStyle/>
+          <a:p>
+            <a:pPr algn="l"/>
+            <a:r>
+              <a:rPr sz="850" b="1" i="0">
                 <a:solidFill>
                   <a:srgbClr val="ECF1F9"/>
                 </a:solidFill>
                 <a:latin typeface="Segoe UI"/>
               </a:rPr>
-              <a:t>Selvedge Denim·Meta·Broad</a:t>
-            </a:r>
-          </a:p>
-        </p:txBody>
-      </p:sp>
-      <p:sp>
-        <p:nvSpPr>
-          <p:cNvPr id="55" name="Rounded Rectangle 54"/>
+              <a:t>Nike Free X Metcon 2·Meta·Broad</a:t>
+            </a:r>
+          </a:p>
+        </p:txBody>
+      </p:sp>
+      <p:sp>
+        <p:nvSpPr>
+          <p:cNvPr id="63" name="Rounded Rectangle 62"/>
           <p:cNvSpPr/>
           <p:nvPr/>
         </p:nvSpPr>
         <p:spPr>
           <a:xfrm>
-            <a:off x="8247888" y="4160520"/>
-            <a:ext cx="749808" cy="310896"/>
+            <a:off x="7607808" y="4160520"/>
+            <a:ext cx="731520" cy="310896"/>
           </a:xfrm>
           <a:prstGeom prst="roundRect">
             <a:avLst>
@@ -17877,27 +18890,27 @@
           <a:p>
             <a:pPr algn="ctr"/>
             <a:r>
-              <a:rPr sz="1000" b="1">
-                <a:solidFill>
-                  <a:srgbClr val="F87171"/>
-                </a:solidFill>
-                <a:latin typeface="Segoe UI"/>
-              </a:rPr>
-              <a:t>−₹7k</a:t>
-            </a:r>
-          </a:p>
-        </p:txBody>
-      </p:sp>
-      <p:sp>
-        <p:nvSpPr>
-          <p:cNvPr id="56" name="Rounded Rectangle 55"/>
+              <a:rPr sz="900" b="1">
+                <a:solidFill>
+                  <a:srgbClr val="8F9DB8"/>
+                </a:solidFill>
+                <a:latin typeface="Segoe UI"/>
+              </a:rPr>
+              <a:t>hold</a:t>
+            </a:r>
+          </a:p>
+        </p:txBody>
+      </p:sp>
+      <p:sp>
+        <p:nvSpPr>
+          <p:cNvPr id="64" name="Rounded Rectangle 63"/>
           <p:cNvSpPr/>
           <p:nvPr/>
         </p:nvSpPr>
         <p:spPr>
           <a:xfrm>
-            <a:off x="9089136" y="4160520"/>
-            <a:ext cx="749808" cy="310896"/>
+            <a:off x="8412480" y="4160520"/>
+            <a:ext cx="731520" cy="310896"/>
           </a:xfrm>
           <a:prstGeom prst="roundRect">
             <a:avLst>
@@ -17932,27 +18945,27 @@
           <a:p>
             <a:pPr algn="ctr"/>
             <a:r>
-              <a:rPr sz="1000" b="1">
-                <a:solidFill>
-                  <a:srgbClr val="F87171"/>
-                </a:solidFill>
-                <a:latin typeface="Segoe UI"/>
-              </a:rPr>
-              <a:t>−₹7k</a:t>
-            </a:r>
-          </a:p>
-        </p:txBody>
-      </p:sp>
-      <p:sp>
-        <p:nvSpPr>
-          <p:cNvPr id="57" name="Rounded Rectangle 56"/>
+              <a:rPr sz="900" b="1">
+                <a:solidFill>
+                  <a:srgbClr val="8F9DB8"/>
+                </a:solidFill>
+                <a:latin typeface="Segoe UI"/>
+              </a:rPr>
+              <a:t>hold</a:t>
+            </a:r>
+          </a:p>
+        </p:txBody>
+      </p:sp>
+      <p:sp>
+        <p:nvSpPr>
+          <p:cNvPr id="65" name="Rounded Rectangle 64"/>
           <p:cNvSpPr/>
           <p:nvPr/>
         </p:nvSpPr>
         <p:spPr>
           <a:xfrm>
-            <a:off x="9930384" y="4160520"/>
-            <a:ext cx="749808" cy="310896"/>
+            <a:off x="9217152" y="4160520"/>
+            <a:ext cx="731520" cy="310896"/>
           </a:xfrm>
           <a:prstGeom prst="roundRect">
             <a:avLst>
@@ -17987,27 +19000,27 @@
           <a:p>
             <a:pPr algn="ctr"/>
             <a:r>
-              <a:rPr sz="1000" b="1">
-                <a:solidFill>
-                  <a:srgbClr val="F87171"/>
-                </a:solidFill>
-                <a:latin typeface="Segoe UI"/>
-              </a:rPr>
-              <a:t>PAUSE</a:t>
-            </a:r>
-          </a:p>
-        </p:txBody>
-      </p:sp>
-      <p:sp>
-        <p:nvSpPr>
-          <p:cNvPr id="58" name="Rounded Rectangle 57"/>
+              <a:rPr sz="900" b="1">
+                <a:solidFill>
+                  <a:srgbClr val="8F9DB8"/>
+                </a:solidFill>
+                <a:latin typeface="Segoe UI"/>
+              </a:rPr>
+              <a:t>hold</a:t>
+            </a:r>
+          </a:p>
+        </p:txBody>
+      </p:sp>
+      <p:sp>
+        <p:nvSpPr>
+          <p:cNvPr id="66" name="Rounded Rectangle 65"/>
           <p:cNvSpPr/>
           <p:nvPr/>
         </p:nvSpPr>
         <p:spPr>
           <a:xfrm>
-            <a:off x="10771632" y="4160520"/>
-            <a:ext cx="749808" cy="310896"/>
+            <a:off x="10021824" y="4160520"/>
+            <a:ext cx="731520" cy="310896"/>
           </a:xfrm>
           <a:prstGeom prst="roundRect">
             <a:avLst>
@@ -18042,20 +19055,75 @@
           <a:p>
             <a:pPr algn="ctr"/>
             <a:r>
-              <a:rPr sz="1000" b="1">
+              <a:rPr sz="900" b="1">
                 <a:solidFill>
                   <a:srgbClr val="F87171"/>
                 </a:solidFill>
                 <a:latin typeface="Segoe UI"/>
               </a:rPr>
-              <a:t>−₹7k</a:t>
-            </a:r>
-          </a:p>
-        </p:txBody>
-      </p:sp>
-      <p:sp>
-        <p:nvSpPr>
-          <p:cNvPr id="59" name="Rounded Rectangle 58"/>
+              <a:t>PAUSE</a:t>
+            </a:r>
+          </a:p>
+        </p:txBody>
+      </p:sp>
+      <p:sp>
+        <p:nvSpPr>
+          <p:cNvPr id="67" name="Rounded Rectangle 66"/>
+          <p:cNvSpPr/>
+          <p:nvPr/>
+        </p:nvSpPr>
+        <p:spPr>
+          <a:xfrm>
+            <a:off x="10826496" y="4160520"/>
+            <a:ext cx="731520" cy="310896"/>
+          </a:xfrm>
+          <a:prstGeom prst="roundRect">
+            <a:avLst>
+              <a:gd name="adj" fmla="val 50000"/>
+            </a:avLst>
+          </a:prstGeom>
+          <a:solidFill>
+            <a:srgbClr val="1A253D"/>
+          </a:solidFill>
+          <a:ln>
+            <a:noFill/>
+          </a:ln>
+          <a:effectLst/>
+        </p:spPr>
+        <p:style>
+          <a:lnRef idx="1">
+            <a:schemeClr val="accent1"/>
+          </a:lnRef>
+          <a:fillRef idx="3">
+            <a:schemeClr val="accent1"/>
+          </a:fillRef>
+          <a:effectRef idx="2">
+            <a:schemeClr val="accent1"/>
+          </a:effectRef>
+          <a:fontRef idx="minor">
+            <a:schemeClr val="lt1"/>
+          </a:fontRef>
+        </p:style>
+        <p:txBody>
+          <a:bodyPr rtlCol="0" anchor="ctr" lIns="45720" rIns="45720" tIns="0" bIns="0"/>
+          <a:lstStyle/>
+          <a:p>
+            <a:pPr algn="ctr"/>
+            <a:r>
+              <a:rPr sz="900" b="1">
+                <a:solidFill>
+                  <a:srgbClr val="8F9DB8"/>
+                </a:solidFill>
+                <a:latin typeface="Segoe UI"/>
+              </a:rPr>
+              <a:t>hold</a:t>
+            </a:r>
+          </a:p>
+        </p:txBody>
+      </p:sp>
+      <p:sp>
+        <p:nvSpPr>
+          <p:cNvPr id="68" name="Rounded Rectangle 67"/>
           <p:cNvSpPr/>
           <p:nvPr/>
         </p:nvSpPr>
@@ -18101,49 +19169,49 @@
       </p:sp>
       <p:sp>
         <p:nvSpPr>
-          <p:cNvPr id="60" name="TextBox 59"/>
-          <p:cNvSpPr txBox="1"/>
-          <p:nvPr/>
-        </p:nvSpPr>
-        <p:spPr>
-          <a:xfrm>
-            <a:off x="6446520" y="4800600"/>
-            <a:ext cx="1783080" cy="502920"/>
-          </a:xfrm>
-          <a:prstGeom prst="rect">
-            <a:avLst/>
-          </a:prstGeom>
-          <a:noFill/>
-        </p:spPr>
-        <p:txBody>
-          <a:bodyPr wrap="square" lIns="0" rIns="0" tIns="0" bIns="0" anchor="t">
-            <a:spAutoFit/>
-          </a:bodyPr>
-          <a:lstStyle/>
-          <a:p>
-            <a:pPr algn="l"/>
-            <a:r>
-              <a:rPr sz="1000" b="1" i="0">
+          <p:cNvPr id="69" name="TextBox 68"/>
+          <p:cNvSpPr txBox="1"/>
+          <p:nvPr/>
+        </p:nvSpPr>
+        <p:spPr>
+          <a:xfrm>
+            <a:off x="6400800" y="4773168"/>
+            <a:ext cx="1188720" cy="548640"/>
+          </a:xfrm>
+          <a:prstGeom prst="rect">
+            <a:avLst/>
+          </a:prstGeom>
+          <a:noFill/>
+        </p:spPr>
+        <p:txBody>
+          <a:bodyPr wrap="square" lIns="0" rIns="0" tIns="0" bIns="0" anchor="t">
+            <a:spAutoFit/>
+          </a:bodyPr>
+          <a:lstStyle/>
+          <a:p>
+            <a:pPr algn="l"/>
+            <a:r>
+              <a:rPr sz="850" b="1" i="0">
                 <a:solidFill>
                   <a:srgbClr val="ECF1F9"/>
                 </a:solidFill>
                 <a:latin typeface="Segoe UI"/>
               </a:rPr>
-              <a:t>Leather Tote·Meta·RT</a:t>
-            </a:r>
-          </a:p>
-        </p:txBody>
-      </p:sp>
-      <p:sp>
-        <p:nvSpPr>
-          <p:cNvPr id="61" name="Rounded Rectangle 60"/>
+              <a:t>Air Jordan 10 Retro·Meta·LAL</a:t>
+            </a:r>
+          </a:p>
+        </p:txBody>
+      </p:sp>
+      <p:sp>
+        <p:nvSpPr>
+          <p:cNvPr id="70" name="Rounded Rectangle 69"/>
           <p:cNvSpPr/>
           <p:nvPr/>
         </p:nvSpPr>
         <p:spPr>
           <a:xfrm>
-            <a:off x="8247888" y="4873752"/>
-            <a:ext cx="749808" cy="310896"/>
+            <a:off x="7607808" y="4873752"/>
+            <a:ext cx="731520" cy="310896"/>
           </a:xfrm>
           <a:prstGeom prst="roundRect">
             <a:avLst>
@@ -18178,27 +19246,27 @@
           <a:p>
             <a:pPr algn="ctr"/>
             <a:r>
-              <a:rPr sz="1000" b="1">
-                <a:solidFill>
-                  <a:srgbClr val="8F9DB8"/>
-                </a:solidFill>
-                <a:latin typeface="Segoe UI"/>
-              </a:rPr>
-              <a:t>hold</a:t>
-            </a:r>
-          </a:p>
-        </p:txBody>
-      </p:sp>
-      <p:sp>
-        <p:nvSpPr>
-          <p:cNvPr id="62" name="Rounded Rectangle 61"/>
+              <a:rPr sz="900" b="1">
+                <a:solidFill>
+                  <a:srgbClr val="F87171"/>
+                </a:solidFill>
+                <a:latin typeface="Segoe UI"/>
+              </a:rPr>
+              <a:t>−₹12k</a:t>
+            </a:r>
+          </a:p>
+        </p:txBody>
+      </p:sp>
+      <p:sp>
+        <p:nvSpPr>
+          <p:cNvPr id="71" name="Rounded Rectangle 70"/>
           <p:cNvSpPr/>
           <p:nvPr/>
         </p:nvSpPr>
         <p:spPr>
           <a:xfrm>
-            <a:off x="9089136" y="4873752"/>
-            <a:ext cx="749808" cy="310896"/>
+            <a:off x="8412480" y="4873752"/>
+            <a:ext cx="731520" cy="310896"/>
           </a:xfrm>
           <a:prstGeom prst="roundRect">
             <a:avLst>
@@ -18233,27 +19301,27 @@
           <a:p>
             <a:pPr algn="ctr"/>
             <a:r>
-              <a:rPr sz="1000" b="1">
+              <a:rPr sz="900" b="1">
                 <a:solidFill>
                   <a:srgbClr val="F87171"/>
                 </a:solidFill>
                 <a:latin typeface="Segoe UI"/>
               </a:rPr>
-              <a:t>−₹3k</a:t>
-            </a:r>
-          </a:p>
-        </p:txBody>
-      </p:sp>
-      <p:sp>
-        <p:nvSpPr>
-          <p:cNvPr id="63" name="Rounded Rectangle 62"/>
+              <a:t>−₹9k</a:t>
+            </a:r>
+          </a:p>
+        </p:txBody>
+      </p:sp>
+      <p:sp>
+        <p:nvSpPr>
+          <p:cNvPr id="72" name="Rounded Rectangle 71"/>
           <p:cNvSpPr/>
           <p:nvPr/>
         </p:nvSpPr>
         <p:spPr>
           <a:xfrm>
-            <a:off x="9930384" y="4873752"/>
-            <a:ext cx="749808" cy="310896"/>
+            <a:off x="9217152" y="4873752"/>
+            <a:ext cx="731520" cy="310896"/>
           </a:xfrm>
           <a:prstGeom prst="roundRect">
             <a:avLst>
@@ -18288,27 +19356,27 @@
           <a:p>
             <a:pPr algn="ctr"/>
             <a:r>
-              <a:rPr sz="1000" b="1">
-                <a:solidFill>
-                  <a:srgbClr val="8F9DB8"/>
-                </a:solidFill>
-                <a:latin typeface="Segoe UI"/>
-              </a:rPr>
-              <a:t>hold</a:t>
-            </a:r>
-          </a:p>
-        </p:txBody>
-      </p:sp>
-      <p:sp>
-        <p:nvSpPr>
-          <p:cNvPr id="64" name="Rounded Rectangle 63"/>
+              <a:rPr sz="900" b="1">
+                <a:solidFill>
+                  <a:srgbClr val="F87171"/>
+                </a:solidFill>
+                <a:latin typeface="Segoe UI"/>
+              </a:rPr>
+              <a:t>−₹9k</a:t>
+            </a:r>
+          </a:p>
+        </p:txBody>
+      </p:sp>
+      <p:sp>
+        <p:nvSpPr>
+          <p:cNvPr id="73" name="Rounded Rectangle 72"/>
           <p:cNvSpPr/>
           <p:nvPr/>
         </p:nvSpPr>
         <p:spPr>
           <a:xfrm>
-            <a:off x="10771632" y="4873752"/>
-            <a:ext cx="749808" cy="310896"/>
+            <a:off x="10021824" y="4873752"/>
+            <a:ext cx="731520" cy="310896"/>
           </a:xfrm>
           <a:prstGeom prst="roundRect">
             <a:avLst>
@@ -18343,7 +19411,7 @@
           <a:p>
             <a:pPr algn="ctr"/>
             <a:r>
-              <a:rPr sz="1000" b="1">
+              <a:rPr sz="900" b="1">
                 <a:solidFill>
                   <a:srgbClr val="8F9DB8"/>
                 </a:solidFill>
@@ -18356,18 +19424,18 @@
       </p:sp>
       <p:sp>
         <p:nvSpPr>
-          <p:cNvPr id="65" name="Rounded Rectangle 64"/>
+          <p:cNvPr id="74" name="Rounded Rectangle 73"/>
           <p:cNvSpPr/>
           <p:nvPr/>
         </p:nvSpPr>
         <p:spPr>
           <a:xfrm>
-            <a:off x="6309360" y="5577840"/>
-            <a:ext cx="5303520" cy="749808"/>
+            <a:off x="10826496" y="4873752"/>
+            <a:ext cx="731520" cy="310896"/>
           </a:xfrm>
           <a:prstGeom prst="roundRect">
             <a:avLst>
-              <a:gd name="adj" fmla="val 6000"/>
+              <a:gd name="adj" fmla="val 50000"/>
             </a:avLst>
           </a:prstGeom>
           <a:solidFill>
@@ -18393,6 +19461,61 @@
           </a:fontRef>
         </p:style>
         <p:txBody>
+          <a:bodyPr rtlCol="0" anchor="ctr" lIns="45720" rIns="45720" tIns="0" bIns="0"/>
+          <a:lstStyle/>
+          <a:p>
+            <a:pPr algn="ctr"/>
+            <a:r>
+              <a:rPr sz="900" b="1">
+                <a:solidFill>
+                  <a:srgbClr val="F87171"/>
+                </a:solidFill>
+                <a:latin typeface="Segoe UI"/>
+              </a:rPr>
+              <a:t>−₹12k</a:t>
+            </a:r>
+          </a:p>
+        </p:txBody>
+      </p:sp>
+      <p:sp>
+        <p:nvSpPr>
+          <p:cNvPr id="75" name="Rounded Rectangle 74"/>
+          <p:cNvSpPr/>
+          <p:nvPr/>
+        </p:nvSpPr>
+        <p:spPr>
+          <a:xfrm>
+            <a:off x="6309360" y="5577840"/>
+            <a:ext cx="5303520" cy="749808"/>
+          </a:xfrm>
+          <a:prstGeom prst="roundRect">
+            <a:avLst>
+              <a:gd name="adj" fmla="val 6000"/>
+            </a:avLst>
+          </a:prstGeom>
+          <a:solidFill>
+            <a:srgbClr val="1A253D"/>
+          </a:solidFill>
+          <a:ln>
+            <a:noFill/>
+          </a:ln>
+          <a:effectLst/>
+        </p:spPr>
+        <p:style>
+          <a:lnRef idx="1">
+            <a:schemeClr val="accent1"/>
+          </a:lnRef>
+          <a:fillRef idx="3">
+            <a:schemeClr val="accent1"/>
+          </a:fillRef>
+          <a:effectRef idx="2">
+            <a:schemeClr val="accent1"/>
+          </a:effectRef>
+          <a:fontRef idx="minor">
+            <a:schemeClr val="lt1"/>
+          </a:fontRef>
+        </p:style>
+        <p:txBody>
           <a:bodyPr rtlCol="0" anchor="ctr"/>
           <a:lstStyle/>
           <a:p>
@@ -18402,7 +19525,7 @@
       </p:sp>
       <p:sp>
         <p:nvSpPr>
-          <p:cNvPr id="66" name="TextBox 65"/>
+          <p:cNvPr id="76" name="TextBox 75"/>
           <p:cNvSpPr txBox="1"/>
           <p:nvPr/>
         </p:nvSpPr>
@@ -18430,7 +19553,7 @@
                 </a:solidFill>
                 <a:latin typeface="Segoe UI"/>
               </a:rPr>
-              <a:t>Electronics' 5.0× ROAS bar </a:t>
+              <a:t>Lenovo's 6.0× ROAS bar </a:t>
             </a:r>
             <a:r>
               <a:rPr sz="1150" b="0" i="0">
@@ -18439,7 +19562,7 @@
                 </a:solidFill>
                 <a:latin typeface="Segoe UI"/>
               </a:rPr>
-              <a:t>pauses Denim·Meta outright; </a:t>
+              <a:t>cuts hardest; </a:t>
             </a:r>
             <a:r>
               <a:rPr sz="1150" b="1" i="0">
@@ -18448,7 +19571,7 @@
                 </a:solidFill>
                 <a:latin typeface="Segoe UI"/>
               </a:rPr>
-              <a:t>the Startup's growth weight </a:t>
+              <a:t>Nike's growth weight </a:t>
             </a:r>
             <a:r>
               <a:rPr sz="1150" b="0" i="0">
@@ -18457,7 +19580,7 @@
                 </a:solidFill>
                 <a:latin typeface="Segoe UI"/>
               </a:rPr>
-              <a:t>keeps funding prospecting. Same data, different CFO.</a:t>
+              <a:t>keeps funding prospecting. Demo policies, same data, different CFO.</a:t>
             </a:r>
           </a:p>
         </p:txBody>
@@ -18632,7 +19755,7 @@
                 </a:solidFill>
                 <a:latin typeface="Segoe UI"/>
               </a:rPr>
-              <a:t>Live demo anomaly: Linen Blazer · Meta · Lookalike 1%</a:t>
+              <a:t>Live demo anomaly: Air Jordan 10 Retro · Meta · Lookalike 1%</a:t>
             </a:r>
           </a:p>
         </p:txBody>
@@ -18702,7 +19825,7 @@
                 </a:solidFill>
                 <a:latin typeface="Segoe UI"/>
               </a:rPr>
-              <a:t>6 / 12</a:t>
+              <a:t>6 / 13</a:t>
             </a:r>
           </a:p>
         </p:txBody>
@@ -18920,7 +20043,7 @@
                 </a:solidFill>
                 <a:latin typeface="Segoe UI"/>
               </a:rPr>
-              <a:t>Conversion +4%</a:t>
+              <a:t>Conversion +1%</a:t>
             </a:r>
           </a:p>
         </p:txBody>
@@ -19091,7 +20214,7 @@
                 </a:solidFill>
                 <a:latin typeface="Segoe UI"/>
               </a:rPr>
-              <a:t>ROAS fell 51% (from 6.00 to 2.96). CTR dropped 48% and CPC rose 111% while conversion rate held (+4%). Frequency is up 155% on a 49-day-old creative.</a:t>
+              <a:t>ROAS fell 52% (from 7.16 to 3.43). CTR dropped 48% and CPC rose 111% while conversion rate held (+1%). Frequency is up 155% on a 49-day-old creative.</a:t>
             </a:r>
           </a:p>
         </p:txBody>
@@ -19476,7 +20599,7 @@
                 </a:solidFill>
                 <a:latin typeface="Segoe UI"/>
               </a:rPr>
-              <a:t>Move ₹12,000/day — and it earns ₹28,513/day more</a:t>
+              <a:t>Move ₹11,000/day — and it earns ₹23,536/day more</a:t>
             </a:r>
           </a:p>
         </p:txBody>
@@ -19581,7 +20704,7 @@
                 </a:solidFill>
                 <a:latin typeface="Segoe UI"/>
               </a:rPr>
-              <a:t>7 / 12</a:t>
+              <a:t>7 / 13</a:t>
             </a:r>
           </a:p>
         </p:txBody>
@@ -19717,7 +20840,7 @@
                 </a:solidFill>
                 <a:latin typeface="Segoe UI"/>
               </a:rPr>
-              <a:t>₹12,000/day</a:t>
+              <a:t>₹11,000/day</a:t>
             </a:r>
           </a:p>
         </p:txBody>
@@ -19752,7 +20875,7 @@
                 </a:solidFill>
                 <a:latin typeface="Segoe UI"/>
               </a:rPr>
-              <a:t>Linen Blazer·Meta·LAL</a:t>
+              <a:t>Air Jordan 10 Retro·Meta·LAL</a:t>
             </a:r>
           </a:p>
           <a:p>
@@ -19764,7 +20887,7 @@
                 </a:solidFill>
                 <a:latin typeface="Segoe UI"/>
               </a:rPr>
-              <a:t>→ Silk Scarf·Google·Interest</a:t>
+              <a:t>→ Nike Zoom Fly·Google·Interest</a:t>
             </a:r>
           </a:p>
         </p:txBody>
@@ -19845,7 +20968,7 @@
                 </a:solidFill>
                 <a:latin typeface="Segoe UI"/>
               </a:rPr>
-              <a:t>2.1×</a:t>
+              <a:t>2.2×</a:t>
             </a:r>
           </a:p>
         </p:txBody>
@@ -19961,7 +21084,7 @@
                 </a:solidFill>
                 <a:latin typeface="Segoe UI"/>
               </a:rPr>
-              <a:t>5.7×</a:t>
+              <a:t>6.5×</a:t>
             </a:r>
           </a:p>
         </p:txBody>
@@ -20112,7 +21235,7 @@
                 </a:solidFill>
                 <a:latin typeface="Segoe UI"/>
               </a:rPr>
-              <a:t>• 67% unit margin, 32 days of stock cover</a:t>
+              <a:t>• 50% unit margin, 41 days of stock cover</a:t>
             </a:r>
           </a:p>
           <a:p>
@@ -20124,7 +21247,7 @@
                 </a:solidFill>
                 <a:latin typeface="Segoe UI"/>
               </a:rPr>
-              <a:t>• Fashion policy: profitability 28%, risk 25%</a:t>
+              <a:t>• Nike demo policy: profitability 24%, risk 15%</a:t>
             </a:r>
           </a:p>
           <a:p>
@@ -20136,7 +21259,7 @@
                 </a:solidFill>
                 <a:latin typeface="Segoe UI"/>
               </a:rPr>
-              <a:t>• Plan total: +₹84,751/day at the same total spend</a:t>
+              <a:t>• Plan total: +₹81,819/day at the same total spend</a:t>
             </a:r>
           </a:p>
         </p:txBody>
@@ -20311,7 +21434,7 @@
                 </a:solidFill>
                 <a:latin typeface="Segoe UI"/>
               </a:rPr>
-              <a:t>Scenario: a supplier delay leaves only 200 Silk Scarves in stock (from 2,300).</a:t>
+              <a:t>Scenario: a supplier delay leaves only 105 units of Nike Zoom Fly in stock (from 984).</a:t>
             </a:r>
           </a:p>
         </p:txBody>
@@ -20381,7 +21504,7 @@
                 </a:solidFill>
                 <a:latin typeface="Segoe UI"/>
               </a:rPr>
-              <a:t>8 / 12</a:t>
+              <a:t>8 / 13</a:t>
             </a:r>
           </a:p>
         </p:txBody>
@@ -20541,9 +21664,9 @@
                 </a:solidFill>
                 <a:latin typeface="Segoe UI"/>
               </a:rPr>
-              <a:t>Move ₹12,000/day
-Linen Blazer·Meta·LAL
-→ Silk Scarf·Google·Interest</a:t>
+              <a:t>Move ₹11,000/day
+Air Jordan 10 Retro·Meta·LAL
+→ Nike Zoom Fly·Google·Interest</a:t>
             </a:r>
           </a:p>
         </p:txBody>
@@ -20578,7 +21701,7 @@
                 </a:solidFill>
                 <a:latin typeface="Segoe UI"/>
               </a:rPr>
-              <a:t>Scarf has 32 days of cover; scaling it is safe.</a:t>
+              <a:t>Nike Zoom Fly has 41 days of cover; scaling it is safe.</a:t>
             </a:r>
           </a:p>
         </p:txBody>
@@ -20613,7 +21736,7 @@
                 </a:solidFill>
                 <a:latin typeface="Segoe UI"/>
               </a:rPr>
-              <a:t>+₹28,513/day</a:t>
+              <a:t>+₹23,536/day</a:t>
             </a:r>
           </a:p>
         </p:txBody>
@@ -20864,9 +21987,9 @@
                 </a:solidFill>
                 <a:latin typeface="Segoe UI"/>
               </a:rPr>
-              <a:t>Move ₹6,000/day
-Linen Blazer·Meta·LAL
-→ Selvedge Denim·Google·RT</a:t>
+              <a:t>Move ₹12,000/day
+Air Jordan 10 Retro·Meta·LAL
+→ Air Jordan 10 Retro·Google·RT</a:t>
             </a:r>
           </a:p>
         </p:txBody>
@@ -20901,7 +22024,7 @@
                 </a:solidFill>
                 <a:latin typeface="Segoe UI"/>
               </a:rPr>
-              <a:t>Scarf has 2.8 days of cover vs an 18-day restock — scaling would stock out.</a:t>
+              <a:t>Nike Zoom Fly has 4.4 days of cover vs a 25-day restock — scaling would stock out.</a:t>
             </a:r>
           </a:p>
         </p:txBody>
@@ -20936,7 +22059,7 @@
                 </a:solidFill>
                 <a:latin typeface="Segoe UI"/>
               </a:rPr>
-              <a:t>+₹6,591/day</a:t>
+              <a:t>+₹16,649/day</a:t>
             </a:r>
           </a:p>
         </p:txBody>
@@ -21546,7 +22669,7 @@
                 </a:solidFill>
                 <a:latin typeface="Segoe UI"/>
               </a:rPr>
-              <a:t>9 / 12</a:t>
+              <a:t>9 / 13</a:t>
             </a:r>
           </a:p>
         </p:txBody>
@@ -21706,7 +22829,7 @@
                 </a:solidFill>
                 <a:latin typeface="Segoe UI"/>
               </a:rPr>
-              <a:t>+₹28,513/day</a:t>
+              <a:t>+₹23,536/day</a:t>
             </a:r>
           </a:p>
         </p:txBody>
@@ -22098,7 +23221,7 @@
                 </a:solidFill>
                 <a:latin typeface="Segoe UI"/>
               </a:rPr>
-              <a:t>+₹24,952/day</a:t>
+              <a:t>+₹19,508/day</a:t>
             </a:r>
           </a:p>
         </p:txBody>
@@ -22294,7 +23417,7 @@
                 </a:solidFill>
                 <a:latin typeface="Segoe UI"/>
               </a:rPr>
-              <a:t>-12.5%</a:t>
+              <a:t>-17.1%</a:t>
             </a:r>
           </a:p>
         </p:txBody>
@@ -22490,7 +23613,7 @@
                 </a:solidFill>
                 <a:latin typeface="Segoe UI"/>
               </a:rPr>
-              <a:t>92% → 91%</a:t>
+              <a:t>89% → 87%</a:t>
             </a:r>
           </a:p>
         </p:txBody>
@@ -22807,7 +23930,7 @@
                 </a:solidFill>
                 <a:latin typeface="Segoe UI"/>
               </a:rPr>
-              <a:t>• seeded history: 24 past decisions across 4 companies</a:t>
+              <a:t>• seeded history: 6 past decisions per brand</a:t>
             </a:r>
           </a:p>
         </p:txBody>

</xml_diff>